<commit_message>
slides(advisor): light theme + threaded IoT example panel
Convert advisor-meeting deck from the warm-dark IBM-Plex palette to a
cool-clean white/slate light theme so it prints and screen-shares more
faithfully. Thread a single running case ("거실 조명을 50%로 켜줘")
through every content slide via a top-mounted EXAMPLE PROBE bar that
shows how the same user input is transformed at each pipeline stage
(IR emit → trace record → synth gold pair → grammar+post-correct →
re-fed gold → measured tok/lat), so the audience can track one concrete
example end-to-end instead of seeing a new toy case per slide.

Also re-anchors card text frames to TOP (LibreOffice was vertically
centering them) and re-derives slide-3 node/connector y-coordinates
so the pipeline diagram no longer overlaps the new probe bar.

Co-Authored-By: Claude Opus 4.7 <noreply@anthropic.com>
</commit_message>
<xml_diff>
--- a/web/slides.pptx
+++ b/web/slides.pptx
@@ -518,6 +518,12 @@
               <a:t>저희 프레임워크는 소형 모델의 학습 파이프라인인 Reflex-LM과 호스트 단의 검증/보정을 맡는 Myelin Compiler의 협력을 핵심 메커니즘으로 취합니다.</a:t>
             </a:r>
           </a:p>
+          <a:p/>
+          <a:p>
+            <a:r>
+              <a:t>발표 전반에 걸쳐 '거실 조명을 50%로 켜줘' 라는 동일한 IoT 사용자 입력이 각 모듈을 거치며 어떻게 변환되는지를 슬라이드 상단의 EXAMPLE PROBE로 따라가며 시연합니다.</a:t>
+            </a:r>
+          </a:p>
         </p:txBody>
       </p:sp>
       <p:sp>
@@ -594,6 +600,12 @@
               <a:t>둘째, 소형 모델의 추론 한계를 모델 가중치 튜닝과 호스트 컴파일러 최적화의 하이브리드 결합으로 메울 수 있는가 하는 점입니다. 개발자가 기능 명세(Spec)만 던지면 학습 데이터 생성부터 최종 서빙 아티팩트까지 자동 생성하는 Spec-Driven Model Factory의 비전을 담고 있습니다.</a:t>
             </a:r>
           </a:p>
+          <a:p/>
+          <a:p>
+            <a:r>
+              <a:t>상단 EXAMPLE PROBE: 같은 입력 '거실 조명을 50%로 켜줘'에 대해 Native tool-call은 ~287 토큰의 schema를 요구하지만 Action IR은 28 토큰으로 동일한 의미를 전달합니다.</a:t>
+            </a:r>
+          </a:p>
         </p:txBody>
       </p:sp>
       <p:sp>
@@ -670,6 +682,12 @@
               <a:t>자극을 수용하고 변환하는 Dendrite(Contract), 실질적 추론 발화를 수행하는 Soma(LM), 그리고 실행 로그를 분석하고 오류를 정적/동적으로 교정하는 Glia(Analyzer) 레이어로 구성되어 모듈 간 결합도를 최소화했습니다.</a:t>
             </a:r>
           </a:p>
+          <a:p/>
+          <a:p>
+            <a:r>
+              <a:t>상단 EXAMPLE PROBE: 동일한 IoT 입력이 9단계 중 05·TRACE 단계에서 어떻게 정형 트레이스 레코드로 응축되는지 보여줍니다.</a:t>
+            </a:r>
+          </a:p>
         </p:txBody>
       </p:sp>
       <p:sp>
@@ -746,6 +764,12 @@
               <a:t>이후 극소량의 골드 데이터셋을 통해 초소형 모델(Reflex-LM)에 SFT를 적용하여 포맷 학습을 끝내고, 툴 간의 정확한 선택 선호도를 높이기 위해 DPO 정렬 파이프라인까지 연동 가능한 구조를 완비했습니다.</a:t>
             </a:r>
           </a:p>
+          <a:p/>
+          <a:p>
+            <a:r>
+              <a:t>상단 EXAMPLE PROBE: 본 IoT 입력이 SYNTH 단계에서 (prompt, gold_ir) 골드 페어로 변환되어 SFT 학습 row로 사용됩니다.</a:t>
+            </a:r>
+          </a:p>
         </p:txBody>
       </p:sp>
       <p:sp>
@@ -822,6 +846,12 @@
               <a:t>첫째로, 도구 명세로부터 EBNF 문법을 실시간 생성하여 디코딩 시점에서 유효한 Action IR만 출력되도록 토큰 마스킹을 수행합니다. 둘째로, 그럼에도 발생하는 인자 누락이나 논리 에러는 호스트 단의 Myelin Compiler가 감지하여 디폴트 값을 동적으로 주입하거나, 에러 로그 피드백을 통해 런타임 재시도를 유도하는 이중 방어 체계를 갖췄습니다.</a:t>
             </a:r>
           </a:p>
+          <a:p/>
+          <a:p>
+            <a:r>
+              <a:t>상단 EXAMPLE PROBE: 모델이 비정규(room='거실') 값을 뱉고 level 인자를 누락해도 alias 매핑(거실→living)과 default 주입(level=100)으로 즉시 복원됩니다.</a:t>
+            </a:r>
+          </a:p>
         </p:txBody>
       </p:sp>
       <p:sp>
@@ -898,6 +928,12 @@
               <a:t>최종적으로 보정이나 재시도를 거쳐 '성공으로 복구된 Action IR' 로그를 정제하여 다음 세대 모델의 SFT 데이터로 재피딩(Re-feeding)함으로써 모델을 점점 강건하게 진화시키는 자가 증강 루프를 지원합니다.</a:t>
             </a:r>
           </a:p>
+          <a:p/>
+          <a:p>
+            <a:r>
+              <a:t>상단 EXAMPLE PROBE: 본 IoT 입력의 trace.repaired 레코드가 다음 세대 SFT 골드 row로 환원되는 과정을 보여줍니다.</a:t>
+            </a:r>
+          </a:p>
         </p:txBody>
       </p:sp>
       <p:sp>
@@ -978,6 +1014,12 @@
           <a:p>
             <a:r>
               <a:t>또한 호출 거부 문맥(Irrelevance)에서도 No-Call 정확도 100%를 달성하였으며, 이는 명세 기반 SFT와 Myelin Compiler의 사후 규칙 보정(Post-Correction) 조합이 초소형 모델의 한계를 완전히 극복할 수 있음을 증명합니다.</a:t>
+            </a:r>
+          </a:p>
+          <a:p/>
+          <a:p>
+            <a:r>
+              <a:t>상단 EXAMPLE PROBE: 본 IoT 입력 단일 케이스에서 측정된 Native vs Ganglion 비교 수치입니다 (287→92 tok, 482→391 ms).</a:t>
             </a:r>
           </a:p>
         </p:txBody>
@@ -4061,7 +4103,7 @@
     <p:bg>
       <p:bgPr>
         <a:solidFill>
-          <a:srgbClr val="0E0E0C"/>
+          <a:srgbClr val="FFFFFF"/>
         </a:solidFill>
         <a:effectLst/>
       </p:bgPr>
@@ -4090,7 +4132,7 @@
           <a:noFill/>
           <a:ln w="12700">
             <a:solidFill>
-              <a:srgbClr val="2A2A26"/>
+              <a:srgbClr val="E2E8F0"/>
             </a:solidFill>
           </a:ln>
         </p:spPr>
@@ -4124,18 +4166,18 @@
         </p:nvSpPr>
         <p:spPr>
           <a:xfrm>
-            <a:off x="1371600" y="1645920"/>
+            <a:off x="1371600" y="1463040"/>
             <a:ext cx="3200400" cy="365760"/>
           </a:xfrm>
           <a:prstGeom prst="rect">
             <a:avLst/>
           </a:prstGeom>
           <a:solidFill>
-            <a:srgbClr val="181814"/>
+            <a:srgbClr val="F8FAFC"/>
           </a:solidFill>
           <a:ln w="12700">
             <a:solidFill>
-              <a:srgbClr val="7DD8C6"/>
+              <a:srgbClr val="0F766E"/>
             </a:solidFill>
           </a:ln>
         </p:spPr>
@@ -4160,7 +4202,7 @@
             <a:pPr algn="ctr">
               <a:defRPr sz="1100" b="1">
                 <a:solidFill>
-                  <a:srgbClr val="7DD8C6"/>
+                  <a:srgbClr val="0F766E"/>
                 </a:solidFill>
                 <a:latin typeface="IBM Plex Mono"/>
               </a:defRPr>
@@ -4179,7 +4221,7 @@
         </p:nvSpPr>
         <p:spPr>
           <a:xfrm>
-            <a:off x="1371600" y="2194560"/>
+            <a:off x="1371600" y="2011680"/>
             <a:ext cx="9418320" cy="1645920"/>
           </a:xfrm>
           <a:prstGeom prst="rect">
@@ -4196,7 +4238,7 @@
             <a:pPr>
               <a:defRPr sz="3600" b="1">
                 <a:solidFill>
-                  <a:srgbClr val="FFFCF0"/>
+                  <a:srgbClr val="0F172A"/>
                 </a:solidFill>
                 <a:latin typeface="IBM Plex Mono"/>
               </a:defRPr>
@@ -4207,7 +4249,7 @@
             <a:r>
               <a:rPr sz="3600" b="1">
                 <a:solidFill>
-                  <a:srgbClr val="C3E88D"/>
+                  <a:srgbClr val="4D7C0F"/>
                 </a:solidFill>
                 <a:latin typeface="IBM Plex Mono"/>
               </a:rPr>
@@ -4216,7 +4258,7 @@
             <a:r>
               <a:rPr sz="3600" b="1">
                 <a:solidFill>
-                  <a:srgbClr val="FFFCF0"/>
+                  <a:srgbClr val="0F172A"/>
                 </a:solidFill>
                 <a:latin typeface="IBM Plex Mono"/>
               </a:rPr>
@@ -4234,8 +4276,8 @@
         </p:nvSpPr>
         <p:spPr>
           <a:xfrm>
-            <a:off x="1371600" y="3931920"/>
-            <a:ext cx="9418320" cy="914400"/>
+            <a:off x="1371600" y="3657600"/>
+            <a:ext cx="9418320" cy="822960"/>
           </a:xfrm>
           <a:prstGeom prst="rect">
             <a:avLst/>
@@ -4251,7 +4293,7 @@
             <a:pPr>
               <a:defRPr sz="1500">
                 <a:solidFill>
-                  <a:srgbClr val="9A9485"/>
+                  <a:srgbClr val="64748B"/>
                 </a:solidFill>
                 <a:latin typeface="Arial"/>
               </a:defRPr>
@@ -4268,14 +4310,102 @@
       </p:sp>
       <p:sp>
         <p:nvSpPr>
-          <p:cNvPr id="6" name="TextBox 5"/>
+          <p:cNvPr id="6" name="Rectangle 5"/>
+          <p:cNvSpPr/>
+          <p:nvPr/>
+        </p:nvSpPr>
+        <p:spPr>
+          <a:xfrm>
+            <a:off x="1371600" y="4617720"/>
+            <a:ext cx="9418320" cy="777240"/>
+          </a:xfrm>
+          <a:prstGeom prst="rect">
+            <a:avLst/>
+          </a:prstGeom>
+          <a:solidFill>
+            <a:srgbClr val="F1F5F9"/>
+          </a:solidFill>
+          <a:ln w="9525">
+            <a:solidFill>
+              <a:srgbClr val="0F766E"/>
+            </a:solidFill>
+          </a:ln>
+        </p:spPr>
+        <p:style>
+          <a:lnRef idx="1">
+            <a:schemeClr val="accent1"/>
+          </a:lnRef>
+          <a:fillRef idx="3">
+            <a:schemeClr val="accent1"/>
+          </a:fillRef>
+          <a:effectRef idx="2">
+            <a:schemeClr val="accent1"/>
+          </a:effectRef>
+          <a:fontRef idx="minor">
+            <a:schemeClr val="lt1"/>
+          </a:fontRef>
+        </p:style>
+        <p:txBody>
+          <a:bodyPr rtlCol="0" anchor="t" wrap="square" lIns="182880" rIns="182880" tIns="91440"/>
+          <a:lstStyle/>
+          <a:p>
+            <a:pPr algn="l"/>
+            <a:r>
+              <a:rPr sz="950" b="1">
+                <a:solidFill>
+                  <a:srgbClr val="0F766E"/>
+                </a:solidFill>
+                <a:latin typeface="IBM Plex Mono"/>
+              </a:rPr>
+              <a:t>EXAMPLE PROBE</a:t>
+            </a:r>
+            <a:r>
+              <a:rPr sz="950">
+                <a:solidFill>
+                  <a:srgbClr val="64748B"/>
+                </a:solidFill>
+                <a:latin typeface="IBM Plex Mono"/>
+              </a:rPr>
+              <a:t>   동일한 IoT 사용자 입력이 각 모듈에서 어떻게 변환되는지를 매 슬라이드 상단의 PROBE 패널에서 추적합니다</a:t>
+            </a:r>
+          </a:p>
+          <a:p>
+            <a:pPr algn="l">
+              <a:spcBef>
+                <a:spcPts val="300"/>
+              </a:spcBef>
+            </a:pPr>
+            <a:r>
+              <a:rPr sz="1300" b="1">
+                <a:solidFill>
+                  <a:srgbClr val="0F766E"/>
+                </a:solidFill>
+                <a:latin typeface="IBM Plex Mono"/>
+              </a:rPr>
+              <a:t>▸  </a:t>
+            </a:r>
+            <a:r>
+              <a:rPr sz="1300" b="1">
+                <a:solidFill>
+                  <a:srgbClr val="0F172A"/>
+                </a:solidFill>
+                <a:latin typeface="IBM Plex Mono"/>
+              </a:rPr>
+              <a:t>“거실 조명을 50%로 켜줘”</a:t>
+            </a:r>
+          </a:p>
+        </p:txBody>
+      </p:sp>
+      <p:sp>
+        <p:nvSpPr>
+          <p:cNvPr id="7" name="TextBox 6"/>
           <p:cNvSpPr txBox="1"/>
           <p:nvPr/>
         </p:nvSpPr>
         <p:spPr>
           <a:xfrm>
-            <a:off x="1371600" y="5029200"/>
-            <a:ext cx="9418320" cy="731520"/>
+            <a:off x="1371600" y="5532120"/>
+            <a:ext cx="9418320" cy="594360"/>
           </a:xfrm>
           <a:prstGeom prst="rect">
             <a:avLst/>
@@ -4291,7 +4421,7 @@
             <a:pPr>
               <a:defRPr sz="1200">
                 <a:solidFill>
-                  <a:srgbClr val="5C564B"/>
+                  <a:srgbClr val="94A3B8"/>
                 </a:solidFill>
                 <a:latin typeface="IBM Plex Mono"/>
               </a:defRPr>
@@ -4320,7 +4450,7 @@
     <p:bg>
       <p:bgPr>
         <a:solidFill>
-          <a:srgbClr val="0E0E0C"/>
+          <a:srgbClr val="FFFFFF"/>
         </a:solidFill>
         <a:effectLst/>
       </p:bgPr>
@@ -4357,7 +4487,7 @@
             <a:pPr>
               <a:defRPr sz="1000" b="1">
                 <a:solidFill>
-                  <a:srgbClr val="7DD8C6"/>
+                  <a:srgbClr val="0F766E"/>
                 </a:solidFill>
                 <a:latin typeface="IBM Plex Mono"/>
               </a:defRPr>
@@ -4393,7 +4523,7 @@
             <a:pPr>
               <a:defRPr sz="2400" b="1">
                 <a:solidFill>
-                  <a:srgbClr val="FFFCF0"/>
+                  <a:srgbClr val="0F172A"/>
                 </a:solidFill>
                 <a:latin typeface="IBM Plex Mono"/>
               </a:defRPr>
@@ -4429,7 +4559,7 @@
             <a:pPr algn="r">
               <a:defRPr sz="1100">
                 <a:solidFill>
-                  <a:srgbClr val="5C564B"/>
+                  <a:srgbClr val="94A3B8"/>
                 </a:solidFill>
                 <a:latin typeface="IBM Plex Mono"/>
               </a:defRPr>
@@ -4454,9 +4584,9 @@
           <a:prstGeom prst="line">
             <a:avLst/>
           </a:prstGeom>
-          <a:ln w="19050">
+          <a:ln w="12700">
             <a:solidFill>
-              <a:srgbClr val="2A2A26"/>
+              <a:srgbClr val="E2E8F0"/>
             </a:solidFill>
           </a:ln>
         </p:spPr>
@@ -4483,18 +4613,18 @@
         </p:nvSpPr>
         <p:spPr>
           <a:xfrm>
-            <a:off x="685800" y="1463040"/>
-            <a:ext cx="5303520" cy="2011680"/>
+            <a:off x="685800" y="1280160"/>
+            <a:ext cx="10817352" cy="411480"/>
           </a:xfrm>
           <a:prstGeom prst="rect">
             <a:avLst/>
           </a:prstGeom>
           <a:solidFill>
-            <a:srgbClr val="181814"/>
+            <a:srgbClr val="F1F5F9"/>
           </a:solidFill>
-          <a:ln w="19050">
+          <a:ln w="9525">
             <a:solidFill>
-              <a:srgbClr val="3D3D36"/>
+              <a:srgbClr val="4D7C0F"/>
             </a:solidFill>
           </a:ln>
         </p:spPr>
@@ -4513,7 +4643,104 @@
           </a:fontRef>
         </p:style>
         <p:txBody>
-          <a:bodyPr rtlCol="0" anchor="ctr" wrap="square" lIns="228600" rIns="228600" tIns="182880"/>
+          <a:bodyPr rtlCol="0" anchor="ctr" wrap="square" lIns="164592" rIns="164592" bIns="36576"/>
+          <a:lstStyle/>
+          <a:p>
+            <a:pPr algn="ctr"/>
+            <a:r>
+              <a:rPr sz="850" b="1">
+                <a:solidFill>
+                  <a:srgbClr val="4D7C0F"/>
+                </a:solidFill>
+                <a:latin typeface="IBM Plex Mono"/>
+              </a:rPr>
+              <a:t>EXAMPLE · STAGE · ACTION IR EMIT</a:t>
+            </a:r>
+            <a:r>
+              <a:rPr sz="850">
+                <a:solidFill>
+                  <a:srgbClr val="94A3B8"/>
+                </a:solidFill>
+                <a:latin typeface="IBM Plex Mono"/>
+              </a:rPr>
+              <a:t>    USER INPUT → </a:t>
+            </a:r>
+            <a:r>
+              <a:rPr sz="850" i="1">
+                <a:solidFill>
+                  <a:srgbClr val="64748B"/>
+                </a:solidFill>
+                <a:latin typeface="IBM Plex Mono"/>
+              </a:rPr>
+              <a:t>“거실 조명을 50%로 켜줘”</a:t>
+            </a:r>
+          </a:p>
+          <a:p>
+            <a:pPr>
+              <a:spcBef>
+                <a:spcPts val="100"/>
+              </a:spcBef>
+            </a:pPr>
+            <a:r>
+              <a:rPr sz="1000" b="1">
+                <a:solidFill>
+                  <a:srgbClr val="4D7C0F"/>
+                </a:solidFill>
+                <a:latin typeface="IBM Plex Mono"/>
+              </a:rPr>
+              <a:t>▸  </a:t>
+            </a:r>
+            <a:r>
+              <a:rPr sz="1000" b="1">
+                <a:solidFill>
+                  <a:srgbClr val="0F172A"/>
+                </a:solidFill>
+                <a:latin typeface="IBM Plex Mono"/>
+              </a:rPr>
+              <a:t>IR  {"calls":[{"tool":"set_light","args":{"room":"living","level":50}}]}   ·   28 tok  vs  Native schema 287 tok</a:t>
+            </a:r>
+          </a:p>
+        </p:txBody>
+      </p:sp>
+      <p:sp>
+        <p:nvSpPr>
+          <p:cNvPr id="7" name="Rectangle 6"/>
+          <p:cNvSpPr/>
+          <p:nvPr/>
+        </p:nvSpPr>
+        <p:spPr>
+          <a:xfrm>
+            <a:off x="685800" y="1783080"/>
+            <a:ext cx="5303520" cy="1920240"/>
+          </a:xfrm>
+          <a:prstGeom prst="rect">
+            <a:avLst/>
+          </a:prstGeom>
+          <a:solidFill>
+            <a:srgbClr val="F8FAFC"/>
+          </a:solidFill>
+          <a:ln w="12700">
+            <a:solidFill>
+              <a:srgbClr val="CBD5E1"/>
+            </a:solidFill>
+          </a:ln>
+        </p:spPr>
+        <p:style>
+          <a:lnRef idx="1">
+            <a:schemeClr val="accent1"/>
+          </a:lnRef>
+          <a:fillRef idx="3">
+            <a:schemeClr val="accent1"/>
+          </a:fillRef>
+          <a:effectRef idx="2">
+            <a:schemeClr val="accent1"/>
+          </a:effectRef>
+          <a:fontRef idx="minor">
+            <a:schemeClr val="lt1"/>
+          </a:fontRef>
+        </p:style>
+        <p:txBody>
+          <a:bodyPr rtlCol="0" anchor="t" wrap="square" lIns="228600" rIns="228600" tIns="201168"/>
           <a:lstStyle/>
           <a:p>
             <a:pPr algn="ctr">
@@ -4522,7 +4749,7 @@
               </a:spcAft>
               <a:defRPr sz="1700" b="1">
                 <a:solidFill>
-                  <a:srgbClr val="C3E88D"/>
+                  <a:srgbClr val="4D7C0F"/>
                 </a:solidFill>
                 <a:latin typeface="IBM Plex Mono"/>
               </a:defRPr>
@@ -4535,7 +4762,7 @@
             <a:pPr>
               <a:defRPr sz="1250">
                 <a:solidFill>
-                  <a:srgbClr val="E8E4D4"/>
+                  <a:srgbClr val="334155"/>
                 </a:solidFill>
                 <a:latin typeface="Arial"/>
               </a:defRPr>
@@ -4548,24 +4775,24 @@
       </p:sp>
       <p:sp>
         <p:nvSpPr>
-          <p:cNvPr id="7" name="Rectangle 6"/>
+          <p:cNvPr id="8" name="Rectangle 7"/>
           <p:cNvSpPr/>
           <p:nvPr/>
         </p:nvSpPr>
         <p:spPr>
           <a:xfrm>
-            <a:off x="6199632" y="1463040"/>
-            <a:ext cx="5303520" cy="2011680"/>
+            <a:off x="6199632" y="1783080"/>
+            <a:ext cx="5303520" cy="1920240"/>
           </a:xfrm>
           <a:prstGeom prst="rect">
             <a:avLst/>
           </a:prstGeom>
           <a:solidFill>
-            <a:srgbClr val="181814"/>
+            <a:srgbClr val="F8FAFC"/>
           </a:solidFill>
-          <a:ln w="19050">
+          <a:ln w="12700">
             <a:solidFill>
-              <a:srgbClr val="3D3D36"/>
+              <a:srgbClr val="CBD5E1"/>
             </a:solidFill>
           </a:ln>
         </p:spPr>
@@ -4584,7 +4811,7 @@
           </a:fontRef>
         </p:style>
         <p:txBody>
-          <a:bodyPr rtlCol="0" anchor="ctr" wrap="square" lIns="228600" rIns="228600" tIns="182880"/>
+          <a:bodyPr rtlCol="0" anchor="t" wrap="square" lIns="228600" rIns="228600" tIns="201168"/>
           <a:lstStyle/>
           <a:p>
             <a:pPr algn="ctr">
@@ -4593,7 +4820,7 @@
               </a:spcAft>
               <a:defRPr sz="1700" b="1">
                 <a:solidFill>
-                  <a:srgbClr val="C3E88D"/>
+                  <a:srgbClr val="4D7C0F"/>
                 </a:solidFill>
                 <a:latin typeface="IBM Plex Mono"/>
               </a:defRPr>
@@ -4606,7 +4833,7 @@
             <a:pPr>
               <a:defRPr sz="1250">
                 <a:solidFill>
-                  <a:srgbClr val="E8E4D4"/>
+                  <a:srgbClr val="334155"/>
                 </a:solidFill>
                 <a:latin typeface="Arial"/>
               </a:defRPr>
@@ -4619,24 +4846,24 @@
       </p:sp>
       <p:sp>
         <p:nvSpPr>
-          <p:cNvPr id="8" name="Rectangle 7"/>
+          <p:cNvPr id="9" name="Rectangle 8"/>
           <p:cNvSpPr/>
           <p:nvPr/>
         </p:nvSpPr>
         <p:spPr>
           <a:xfrm>
-            <a:off x="685800" y="3749039"/>
-            <a:ext cx="5303520" cy="2011680"/>
+            <a:off x="685800" y="3840480"/>
+            <a:ext cx="5303520" cy="1920240"/>
           </a:xfrm>
           <a:prstGeom prst="rect">
             <a:avLst/>
           </a:prstGeom>
           <a:solidFill>
-            <a:srgbClr val="181814"/>
+            <a:srgbClr val="F8FAFC"/>
           </a:solidFill>
-          <a:ln w="19050">
+          <a:ln w="12700">
             <a:solidFill>
-              <a:srgbClr val="3D3D36"/>
+              <a:srgbClr val="CBD5E1"/>
             </a:solidFill>
           </a:ln>
         </p:spPr>
@@ -4655,7 +4882,7 @@
           </a:fontRef>
         </p:style>
         <p:txBody>
-          <a:bodyPr rtlCol="0" anchor="ctr" wrap="square" lIns="228600" rIns="228600" tIns="182880"/>
+          <a:bodyPr rtlCol="0" anchor="t" wrap="square" lIns="228600" rIns="228600" tIns="201168"/>
           <a:lstStyle/>
           <a:p>
             <a:pPr algn="ctr">
@@ -4664,7 +4891,7 @@
               </a:spcAft>
               <a:defRPr sz="1700" b="1">
                 <a:solidFill>
-                  <a:srgbClr val="C3E88D"/>
+                  <a:srgbClr val="4D7C0F"/>
                 </a:solidFill>
                 <a:latin typeface="IBM Plex Mono"/>
               </a:defRPr>
@@ -4677,7 +4904,7 @@
             <a:pPr>
               <a:defRPr sz="1250">
                 <a:solidFill>
-                  <a:srgbClr val="E8E4D4"/>
+                  <a:srgbClr val="334155"/>
                 </a:solidFill>
                 <a:latin typeface="Arial"/>
               </a:defRPr>
@@ -4690,24 +4917,24 @@
       </p:sp>
       <p:sp>
         <p:nvSpPr>
-          <p:cNvPr id="9" name="Rectangle 8"/>
+          <p:cNvPr id="10" name="Rectangle 9"/>
           <p:cNvSpPr/>
           <p:nvPr/>
         </p:nvSpPr>
         <p:spPr>
           <a:xfrm>
-            <a:off x="6199632" y="3749039"/>
-            <a:ext cx="5303520" cy="2011680"/>
+            <a:off x="6199632" y="3840480"/>
+            <a:ext cx="5303520" cy="1920240"/>
           </a:xfrm>
           <a:prstGeom prst="rect">
             <a:avLst/>
           </a:prstGeom>
           <a:solidFill>
-            <a:srgbClr val="181814"/>
+            <a:srgbClr val="F8FAFC"/>
           </a:solidFill>
-          <a:ln w="19050">
+          <a:ln w="12700">
             <a:solidFill>
-              <a:srgbClr val="3D3D36"/>
+              <a:srgbClr val="CBD5E1"/>
             </a:solidFill>
           </a:ln>
         </p:spPr>
@@ -4726,7 +4953,7 @@
           </a:fontRef>
         </p:style>
         <p:txBody>
-          <a:bodyPr rtlCol="0" anchor="ctr" wrap="square" lIns="228600" rIns="228600" tIns="182880"/>
+          <a:bodyPr rtlCol="0" anchor="t" wrap="square" lIns="228600" rIns="228600" tIns="201168"/>
           <a:lstStyle/>
           <a:p>
             <a:pPr algn="ctr">
@@ -4735,7 +4962,7 @@
               </a:spcAft>
               <a:defRPr sz="1700" b="1">
                 <a:solidFill>
-                  <a:srgbClr val="C3E88D"/>
+                  <a:srgbClr val="4D7C0F"/>
                 </a:solidFill>
                 <a:latin typeface="IBM Plex Mono"/>
               </a:defRPr>
@@ -4748,7 +4975,7 @@
             <a:pPr>
               <a:defRPr sz="1250">
                 <a:solidFill>
-                  <a:srgbClr val="E8E4D4"/>
+                  <a:srgbClr val="334155"/>
                 </a:solidFill>
                 <a:latin typeface="Arial"/>
               </a:defRPr>
@@ -4761,7 +4988,7 @@
       </p:sp>
       <p:cxnSp>
         <p:nvCxnSpPr>
-          <p:cNvPr id="10" name="Connector 9"/>
+          <p:cNvPr id="11" name="Connector 10"/>
           <p:cNvCxnSpPr/>
           <p:nvPr/>
         </p:nvCxnSpPr>
@@ -4773,9 +5000,9 @@
           <a:prstGeom prst="line">
             <a:avLst/>
           </a:prstGeom>
-          <a:ln w="19050">
+          <a:ln w="12700">
             <a:solidFill>
-              <a:srgbClr val="2A2A26"/>
+              <a:srgbClr val="E2E8F0"/>
             </a:solidFill>
           </a:ln>
         </p:spPr>
@@ -4796,7 +5023,7 @@
       </p:cxnSp>
       <p:sp>
         <p:nvSpPr>
-          <p:cNvPr id="11" name="TextBox 10"/>
+          <p:cNvPr id="12" name="TextBox 11"/>
           <p:cNvSpPr txBox="1"/>
           <p:nvPr/>
         </p:nvSpPr>
@@ -4819,7 +5046,7 @@
             <a:pPr>
               <a:defRPr sz="1000">
                 <a:solidFill>
-                  <a:srgbClr val="5C564B"/>
+                  <a:srgbClr val="94A3B8"/>
                 </a:solidFill>
                 <a:latin typeface="IBM Plex Mono"/>
               </a:defRPr>
@@ -4832,7 +5059,7 @@
       </p:sp>
       <p:sp>
         <p:nvSpPr>
-          <p:cNvPr id="12" name="TextBox 11"/>
+          <p:cNvPr id="13" name="TextBox 12"/>
           <p:cNvSpPr txBox="1"/>
           <p:nvPr/>
         </p:nvSpPr>
@@ -4855,7 +5082,7 @@
             <a:pPr algn="r">
               <a:defRPr sz="1000">
                 <a:solidFill>
-                  <a:srgbClr val="5C564B"/>
+                  <a:srgbClr val="94A3B8"/>
                 </a:solidFill>
                 <a:latin typeface="IBM Plex Mono"/>
               </a:defRPr>
@@ -4880,7 +5107,7 @@
     <p:bg>
       <p:bgPr>
         <a:solidFill>
-          <a:srgbClr val="0E0E0C"/>
+          <a:srgbClr val="FFFFFF"/>
         </a:solidFill>
         <a:effectLst/>
       </p:bgPr>
@@ -4917,7 +5144,7 @@
             <a:pPr>
               <a:defRPr sz="1000" b="1">
                 <a:solidFill>
-                  <a:srgbClr val="7DD8C6"/>
+                  <a:srgbClr val="0F766E"/>
                 </a:solidFill>
                 <a:latin typeface="IBM Plex Mono"/>
               </a:defRPr>
@@ -4953,7 +5180,7 @@
             <a:pPr>
               <a:defRPr sz="2400" b="1">
                 <a:solidFill>
-                  <a:srgbClr val="FFFCF0"/>
+                  <a:srgbClr val="0F172A"/>
                 </a:solidFill>
                 <a:latin typeface="IBM Plex Mono"/>
               </a:defRPr>
@@ -4989,7 +5216,7 @@
             <a:pPr algn="r">
               <a:defRPr sz="1100">
                 <a:solidFill>
-                  <a:srgbClr val="5C564B"/>
+                  <a:srgbClr val="94A3B8"/>
                 </a:solidFill>
                 <a:latin typeface="IBM Plex Mono"/>
               </a:defRPr>
@@ -5014,9 +5241,9 @@
           <a:prstGeom prst="line">
             <a:avLst/>
           </a:prstGeom>
-          <a:ln w="19050">
+          <a:ln w="12700">
             <a:solidFill>
-              <a:srgbClr val="2A2A26"/>
+              <a:srgbClr val="E2E8F0"/>
             </a:solidFill>
           </a:ln>
         </p:spPr>
@@ -5043,18 +5270,18 @@
         </p:nvSpPr>
         <p:spPr>
           <a:xfrm>
-            <a:off x="685800" y="1645920"/>
-            <a:ext cx="1737360" cy="914400"/>
+            <a:off x="685800" y="1280160"/>
+            <a:ext cx="10817352" cy="411480"/>
           </a:xfrm>
           <a:prstGeom prst="rect">
             <a:avLst/>
           </a:prstGeom>
           <a:solidFill>
-            <a:srgbClr val="181814"/>
+            <a:srgbClr val="F1F5F9"/>
           </a:solidFill>
-          <a:ln w="19050">
+          <a:ln w="9525">
             <a:solidFill>
-              <a:srgbClr val="C3E88D"/>
+              <a:srgbClr val="0F766E"/>
             </a:solidFill>
           </a:ln>
         </p:spPr>
@@ -5073,32 +5300,61 @@
           </a:fontRef>
         </p:style>
         <p:txBody>
-          <a:bodyPr rtlCol="0" anchor="ctr" wrap="square" tIns="91440"/>
-          <a:lstStyle/>
-          <a:p>
-            <a:pPr algn="ctr">
-              <a:defRPr sz="1300" b="1">
-                <a:solidFill>
-                  <a:srgbClr val="FFFCF0"/>
-                </a:solidFill>
-                <a:latin typeface="IBM Plex Mono"/>
-              </a:defRPr>
-            </a:pPr>
-            <a:r>
-              <a:t>01 · SYNTH</a:t>
+          <a:bodyPr rtlCol="0" anchor="ctr" wrap="square" lIns="164592" rIns="164592" bIns="36576"/>
+          <a:lstStyle/>
+          <a:p>
+            <a:pPr algn="ctr"/>
+            <a:r>
+              <a:rPr sz="850" b="1">
+                <a:solidFill>
+                  <a:srgbClr val="0F766E"/>
+                </a:solidFill>
+                <a:latin typeface="IBM Plex Mono"/>
+              </a:rPr>
+              <a:t>EXAMPLE · STAGE 05 · TRACE RECORD</a:t>
+            </a:r>
+            <a:r>
+              <a:rPr sz="850">
+                <a:solidFill>
+                  <a:srgbClr val="94A3B8"/>
+                </a:solidFill>
+                <a:latin typeface="IBM Plex Mono"/>
+              </a:rPr>
+              <a:t>    USER INPUT → </a:t>
+            </a:r>
+            <a:r>
+              <a:rPr sz="850" i="1">
+                <a:solidFill>
+                  <a:srgbClr val="64748B"/>
+                </a:solidFill>
+                <a:latin typeface="IBM Plex Mono"/>
+              </a:rPr>
+              <a:t>“거실 조명을 50%로 켜줘”</a:t>
             </a:r>
           </a:p>
           <a:p>
             <a:pPr>
-              <a:defRPr sz="950">
-                <a:solidFill>
-                  <a:srgbClr val="5C564B"/>
-                </a:solidFill>
-                <a:latin typeface="IBM Plex Mono"/>
-              </a:defRPr>
-            </a:pPr>
-            <a:r>
-              <a:t>lm.synth</a:t>
+              <a:spcBef>
+                <a:spcPts val="100"/>
+              </a:spcBef>
+            </a:pPr>
+            <a:r>
+              <a:rPr sz="1000" b="1">
+                <a:solidFill>
+                  <a:srgbClr val="0F766E"/>
+                </a:solidFill>
+                <a:latin typeface="IBM Plex Mono"/>
+              </a:rPr>
+              <a:t>▸  </a:t>
+            </a:r>
+            <a:r>
+              <a:rPr sz="1000" b="1">
+                <a:solidFill>
+                  <a:srgbClr val="0F172A"/>
+                </a:solidFill>
+                <a:latin typeface="IBM Plex Mono"/>
+              </a:rPr>
+              <a:t>Trace{ id:42, prompt:"거실…", ir:{calls:[set_light(living,50)]}, ok:true, latency_ms:391 }</a:t>
             </a:r>
           </a:p>
         </p:txBody>
@@ -5111,18 +5367,18 @@
         </p:nvSpPr>
         <p:spPr>
           <a:xfrm>
-            <a:off x="2926080" y="1645920"/>
+            <a:off x="685800" y="2011680"/>
             <a:ext cx="1737360" cy="914400"/>
           </a:xfrm>
           <a:prstGeom prst="rect">
             <a:avLst/>
           </a:prstGeom>
           <a:solidFill>
-            <a:srgbClr val="181814"/>
+            <a:srgbClr val="F8FAFC"/>
           </a:solidFill>
           <a:ln w="19050">
             <a:solidFill>
-              <a:srgbClr val="C3E88D"/>
+              <a:srgbClr val="4D7C0F"/>
             </a:solidFill>
           </a:ln>
         </p:spPr>
@@ -5147,26 +5403,26 @@
             <a:pPr algn="ctr">
               <a:defRPr sz="1300" b="1">
                 <a:solidFill>
-                  <a:srgbClr val="FFFCF0"/>
-                </a:solidFill>
-                <a:latin typeface="IBM Plex Mono"/>
-              </a:defRPr>
-            </a:pPr>
-            <a:r>
-              <a:t>02 · FINETUNE</a:t>
+                  <a:srgbClr val="0F172A"/>
+                </a:solidFill>
+                <a:latin typeface="IBM Plex Mono"/>
+              </a:defRPr>
+            </a:pPr>
+            <a:r>
+              <a:t>01 · SYNTH</a:t>
             </a:r>
           </a:p>
           <a:p>
             <a:pPr>
               <a:defRPr sz="950">
                 <a:solidFill>
-                  <a:srgbClr val="5C564B"/>
-                </a:solidFill>
-                <a:latin typeface="IBM Plex Mono"/>
-              </a:defRPr>
-            </a:pPr>
-            <a:r>
-              <a:t>lm.finetune</a:t>
+                  <a:srgbClr val="94A3B8"/>
+                </a:solidFill>
+                <a:latin typeface="IBM Plex Mono"/>
+              </a:defRPr>
+            </a:pPr>
+            <a:r>
+              <a:t>lm.synth</a:t>
             </a:r>
           </a:p>
         </p:txBody>
@@ -5179,18 +5435,18 @@
         </p:nvSpPr>
         <p:spPr>
           <a:xfrm>
-            <a:off x="5166360" y="1371600"/>
-            <a:ext cx="1737360" cy="640080"/>
+            <a:off x="2926080" y="2011680"/>
+            <a:ext cx="1737360" cy="914400"/>
           </a:xfrm>
           <a:prstGeom prst="rect">
             <a:avLst/>
           </a:prstGeom>
           <a:solidFill>
-            <a:srgbClr val="181814"/>
+            <a:srgbClr val="F8FAFC"/>
           </a:solidFill>
           <a:ln w="19050">
             <a:solidFill>
-              <a:srgbClr val="9A9485"/>
+              <a:srgbClr val="4D7C0F"/>
             </a:solidFill>
           </a:ln>
         </p:spPr>
@@ -5215,26 +5471,26 @@
             <a:pPr algn="ctr">
               <a:defRPr sz="1300" b="1">
                 <a:solidFill>
-                  <a:srgbClr val="FFFCF0"/>
-                </a:solidFill>
-                <a:latin typeface="IBM Plex Mono"/>
-              </a:defRPr>
-            </a:pPr>
-            <a:r>
-              <a:t>03 · BENCH IOT</a:t>
+                  <a:srgbClr val="0F172A"/>
+                </a:solidFill>
+                <a:latin typeface="IBM Plex Mono"/>
+              </a:defRPr>
+            </a:pPr>
+            <a:r>
+              <a:t>02 · FINETUNE</a:t>
             </a:r>
           </a:p>
           <a:p>
             <a:pPr>
               <a:defRPr sz="950">
                 <a:solidFill>
-                  <a:srgbClr val="5C564B"/>
-                </a:solidFill>
-                <a:latin typeface="IBM Plex Mono"/>
-              </a:defRPr>
-            </a:pPr>
-            <a:r>
-              <a:t>consumer.iot</a:t>
+                  <a:srgbClr val="94A3B8"/>
+                </a:solidFill>
+                <a:latin typeface="IBM Plex Mono"/>
+              </a:defRPr>
+            </a:pPr>
+            <a:r>
+              <a:t>lm.finetune</a:t>
             </a:r>
           </a:p>
         </p:txBody>
@@ -5247,18 +5503,18 @@
         </p:nvSpPr>
         <p:spPr>
           <a:xfrm>
-            <a:off x="5166360" y="2194560"/>
+            <a:off x="5166360" y="1783080"/>
             <a:ext cx="1737360" cy="640080"/>
           </a:xfrm>
           <a:prstGeom prst="rect">
             <a:avLst/>
           </a:prstGeom>
           <a:solidFill>
-            <a:srgbClr val="181814"/>
+            <a:srgbClr val="F8FAFC"/>
           </a:solidFill>
           <a:ln w="19050">
             <a:solidFill>
-              <a:srgbClr val="9A9485"/>
+              <a:srgbClr val="64748B"/>
             </a:solidFill>
           </a:ln>
         </p:spPr>
@@ -5283,26 +5539,26 @@
             <a:pPr algn="ctr">
               <a:defRPr sz="1300" b="1">
                 <a:solidFill>
-                  <a:srgbClr val="FFFCF0"/>
-                </a:solidFill>
-                <a:latin typeface="IBM Plex Mono"/>
-              </a:defRPr>
-            </a:pPr>
-            <a:r>
-              <a:t>04 · BENCH BFCL</a:t>
+                  <a:srgbClr val="0F172A"/>
+                </a:solidFill>
+                <a:latin typeface="IBM Plex Mono"/>
+              </a:defRPr>
+            </a:pPr>
+            <a:r>
+              <a:t>03 · BENCH IOT</a:t>
             </a:r>
           </a:p>
           <a:p>
             <a:pPr>
               <a:defRPr sz="950">
                 <a:solidFill>
-                  <a:srgbClr val="5C564B"/>
-                </a:solidFill>
-                <a:latin typeface="IBM Plex Mono"/>
-              </a:defRPr>
-            </a:pPr>
-            <a:r>
-              <a:t>consumer.bfcl</a:t>
+                  <a:srgbClr val="94A3B8"/>
+                </a:solidFill>
+                <a:latin typeface="IBM Plex Mono"/>
+              </a:defRPr>
+            </a:pPr>
+            <a:r>
+              <a:t>consumer.iot</a:t>
             </a:r>
           </a:p>
         </p:txBody>
@@ -5315,18 +5571,18 @@
         </p:nvSpPr>
         <p:spPr>
           <a:xfrm>
-            <a:off x="7406640" y="1645920"/>
-            <a:ext cx="1737360" cy="914400"/>
+            <a:off x="5166360" y="2560320"/>
+            <a:ext cx="1737360" cy="640080"/>
           </a:xfrm>
           <a:prstGeom prst="rect">
             <a:avLst/>
           </a:prstGeom>
           <a:solidFill>
-            <a:srgbClr val="181814"/>
+            <a:srgbClr val="F8FAFC"/>
           </a:solidFill>
           <a:ln w="19050">
             <a:solidFill>
-              <a:srgbClr val="7DD8C6"/>
+              <a:srgbClr val="64748B"/>
             </a:solidFill>
           </a:ln>
         </p:spPr>
@@ -5351,26 +5607,26 @@
             <a:pPr algn="ctr">
               <a:defRPr sz="1300" b="1">
                 <a:solidFill>
-                  <a:srgbClr val="FFFCF0"/>
-                </a:solidFill>
-                <a:latin typeface="IBM Plex Mono"/>
-              </a:defRPr>
-            </a:pPr>
-            <a:r>
-              <a:t>05 · TRACE</a:t>
+                  <a:srgbClr val="0F172A"/>
+                </a:solidFill>
+                <a:latin typeface="IBM Plex Mono"/>
+              </a:defRPr>
+            </a:pPr>
+            <a:r>
+              <a:t>04 · BENCH BFCL</a:t>
             </a:r>
           </a:p>
           <a:p>
             <a:pPr>
               <a:defRPr sz="950">
                 <a:solidFill>
-                  <a:srgbClr val="5C564B"/>
-                </a:solidFill>
-                <a:latin typeface="IBM Plex Mono"/>
-              </a:defRPr>
-            </a:pPr>
-            <a:r>
-              <a:t>analyzer.trace</a:t>
+                  <a:srgbClr val="94A3B8"/>
+                </a:solidFill>
+                <a:latin typeface="IBM Plex Mono"/>
+              </a:defRPr>
+            </a:pPr>
+            <a:r>
+              <a:t>consumer.bfcl</a:t>
             </a:r>
           </a:p>
         </p:txBody>
@@ -5383,18 +5639,18 @@
         </p:nvSpPr>
         <p:spPr>
           <a:xfrm>
-            <a:off x="7406640" y="3657600"/>
+            <a:off x="7406640" y="2011680"/>
             <a:ext cx="1737360" cy="914400"/>
           </a:xfrm>
           <a:prstGeom prst="rect">
             <a:avLst/>
           </a:prstGeom>
           <a:solidFill>
-            <a:srgbClr val="181814"/>
+            <a:srgbClr val="F8FAFC"/>
           </a:solidFill>
           <a:ln w="19050">
             <a:solidFill>
-              <a:srgbClr val="7DD8C6"/>
+              <a:srgbClr val="0F766E"/>
             </a:solidFill>
           </a:ln>
         </p:spPr>
@@ -5419,26 +5675,26 @@
             <a:pPr algn="ctr">
               <a:defRPr sz="1300" b="1">
                 <a:solidFill>
-                  <a:srgbClr val="FFFCF0"/>
-                </a:solidFill>
-                <a:latin typeface="IBM Plex Mono"/>
-              </a:defRPr>
-            </a:pPr>
-            <a:r>
-              <a:t>06 · TAXONOMY</a:t>
+                  <a:srgbClr val="0F172A"/>
+                </a:solidFill>
+                <a:latin typeface="IBM Plex Mono"/>
+              </a:defRPr>
+            </a:pPr>
+            <a:r>
+              <a:t>05 · TRACE</a:t>
             </a:r>
           </a:p>
           <a:p>
             <a:pPr>
               <a:defRPr sz="950">
                 <a:solidFill>
-                  <a:srgbClr val="5C564B"/>
-                </a:solidFill>
-                <a:latin typeface="IBM Plex Mono"/>
-              </a:defRPr>
-            </a:pPr>
-            <a:r>
-              <a:t>analyzer.errors</a:t>
+                  <a:srgbClr val="94A3B8"/>
+                </a:solidFill>
+                <a:latin typeface="IBM Plex Mono"/>
+              </a:defRPr>
+            </a:pPr>
+            <a:r>
+              <a:t>analyzer.trace</a:t>
             </a:r>
           </a:p>
         </p:txBody>
@@ -5451,18 +5707,18 @@
         </p:nvSpPr>
         <p:spPr>
           <a:xfrm>
-            <a:off x="5166360" y="3657600"/>
+            <a:off x="7406640" y="3931920"/>
             <a:ext cx="1737360" cy="914400"/>
           </a:xfrm>
           <a:prstGeom prst="rect">
             <a:avLst/>
           </a:prstGeom>
           <a:solidFill>
-            <a:srgbClr val="181814"/>
+            <a:srgbClr val="F8FAFC"/>
           </a:solidFill>
           <a:ln w="19050">
             <a:solidFill>
-              <a:srgbClr val="7DD8C6"/>
+              <a:srgbClr val="0F766E"/>
             </a:solidFill>
           </a:ln>
         </p:spPr>
@@ -5487,26 +5743,26 @@
             <a:pPr algn="ctr">
               <a:defRPr sz="1300" b="1">
                 <a:solidFill>
-                  <a:srgbClr val="FFFCF0"/>
-                </a:solidFill>
-                <a:latin typeface="IBM Plex Mono"/>
-              </a:defRPr>
-            </a:pPr>
-            <a:r>
-              <a:t>07 · METRICS</a:t>
+                  <a:srgbClr val="0F172A"/>
+                </a:solidFill>
+                <a:latin typeface="IBM Plex Mono"/>
+              </a:defRPr>
+            </a:pPr>
+            <a:r>
+              <a:t>06 · TAXONOMY</a:t>
             </a:r>
           </a:p>
           <a:p>
             <a:pPr>
               <a:defRPr sz="950">
                 <a:solidFill>
-                  <a:srgbClr val="5C564B"/>
-                </a:solidFill>
-                <a:latin typeface="IBM Plex Mono"/>
-              </a:defRPr>
-            </a:pPr>
-            <a:r>
-              <a:t>analyzer.stats</a:t>
+                  <a:srgbClr val="94A3B8"/>
+                </a:solidFill>
+                <a:latin typeface="IBM Plex Mono"/>
+              </a:defRPr>
+            </a:pPr>
+            <a:r>
+              <a:t>analyzer.errors</a:t>
             </a:r>
           </a:p>
         </p:txBody>
@@ -5519,20 +5775,19 @@
         </p:nvSpPr>
         <p:spPr>
           <a:xfrm>
-            <a:off x="2926080" y="3657600"/>
+            <a:off x="5166360" y="3931920"/>
             <a:ext cx="1737360" cy="914400"/>
           </a:xfrm>
           <a:prstGeom prst="rect">
             <a:avLst/>
           </a:prstGeom>
           <a:solidFill>
-            <a:srgbClr val="181814"/>
+            <a:srgbClr val="F8FAFC"/>
           </a:solidFill>
           <a:ln w="19050">
             <a:solidFill>
-              <a:srgbClr val="F4B860"/>
+              <a:srgbClr val="0F766E"/>
             </a:solidFill>
-            <a:prstDash val="sysDash"/>
           </a:ln>
         </p:spPr>
         <p:style>
@@ -5556,26 +5811,26 @@
             <a:pPr algn="ctr">
               <a:defRPr sz="1300" b="1">
                 <a:solidFill>
-                  <a:srgbClr val="FFFCF0"/>
-                </a:solidFill>
-                <a:latin typeface="IBM Plex Mono"/>
-              </a:defRPr>
-            </a:pPr>
-            <a:r>
-              <a:t>08 · RULES</a:t>
+                  <a:srgbClr val="0F172A"/>
+                </a:solidFill>
+                <a:latin typeface="IBM Plex Mono"/>
+              </a:defRPr>
+            </a:pPr>
+            <a:r>
+              <a:t>07 · METRICS</a:t>
             </a:r>
           </a:p>
           <a:p>
             <a:pPr>
               <a:defRPr sz="950">
                 <a:solidFill>
-                  <a:srgbClr val="5C564B"/>
-                </a:solidFill>
-                <a:latin typeface="IBM Plex Mono"/>
-              </a:defRPr>
-            </a:pPr>
-            <a:r>
-              <a:t>feedback.patch</a:t>
+                  <a:srgbClr val="94A3B8"/>
+                </a:solidFill>
+                <a:latin typeface="IBM Plex Mono"/>
+              </a:defRPr>
+            </a:pPr>
+            <a:r>
+              <a:t>analyzer.stats</a:t>
             </a:r>
           </a:p>
         </p:txBody>
@@ -5588,19 +5843,20 @@
         </p:nvSpPr>
         <p:spPr>
           <a:xfrm>
-            <a:off x="685800" y="3657600"/>
+            <a:off x="2926080" y="3931920"/>
             <a:ext cx="1737360" cy="914400"/>
           </a:xfrm>
           <a:prstGeom prst="rect">
             <a:avLst/>
           </a:prstGeom>
           <a:solidFill>
-            <a:srgbClr val="181814"/>
+            <a:srgbClr val="F8FAFC"/>
           </a:solidFill>
           <a:ln w="19050">
             <a:solidFill>
-              <a:srgbClr val="C3E88D"/>
+              <a:srgbClr val="B45309"/>
             </a:solidFill>
+            <a:prstDash val="sysDash"/>
           </a:ln>
         </p:spPr>
         <p:style>
@@ -5624,65 +5880,98 @@
             <a:pPr algn="ctr">
               <a:defRPr sz="1300" b="1">
                 <a:solidFill>
-                  <a:srgbClr val="FFFCF0"/>
-                </a:solidFill>
-                <a:latin typeface="IBM Plex Mono"/>
-              </a:defRPr>
-            </a:pPr>
-            <a:r>
-              <a:t>09 · PATCH</a:t>
+                  <a:srgbClr val="0F172A"/>
+                </a:solidFill>
+                <a:latin typeface="IBM Plex Mono"/>
+              </a:defRPr>
+            </a:pPr>
+            <a:r>
+              <a:t>08 · RULES</a:t>
             </a:r>
           </a:p>
           <a:p>
             <a:pPr>
               <a:defRPr sz="950">
                 <a:solidFill>
-                  <a:srgbClr val="5C564B"/>
-                </a:solidFill>
-                <a:latin typeface="IBM Plex Mono"/>
-              </a:defRPr>
-            </a:pPr>
-            <a:r>
-              <a:t>contract.update</a:t>
-            </a:r>
-          </a:p>
-        </p:txBody>
-      </p:sp>
-      <p:cxnSp>
-        <p:nvCxnSpPr>
-          <p:cNvPr id="15" name="Connector 14"/>
-          <p:cNvCxnSpPr/>
+                  <a:srgbClr val="94A3B8"/>
+                </a:solidFill>
+                <a:latin typeface="IBM Plex Mono"/>
+              </a:defRPr>
+            </a:pPr>
+            <a:r>
+              <a:t>feedback.patch</a:t>
+            </a:r>
+          </a:p>
+        </p:txBody>
+      </p:sp>
+      <p:sp>
+        <p:nvSpPr>
+          <p:cNvPr id="15" name="Rectangle 14"/>
+          <p:cNvSpPr/>
           <p:nvPr/>
-        </p:nvCxnSpPr>
-        <p:spPr>
-          <a:xfrm>
-            <a:off x="2423160" y="2103120"/>
-            <a:ext cx="502920" cy="0"/>
-          </a:xfrm>
-          <a:prstGeom prst="line">
-            <a:avLst/>
-          </a:prstGeom>
+        </p:nvSpPr>
+        <p:spPr>
+          <a:xfrm>
+            <a:off x="685800" y="3931920"/>
+            <a:ext cx="1737360" cy="914400"/>
+          </a:xfrm>
+          <a:prstGeom prst="rect">
+            <a:avLst/>
+          </a:prstGeom>
+          <a:solidFill>
+            <a:srgbClr val="F8FAFC"/>
+          </a:solidFill>
           <a:ln w="19050">
             <a:solidFill>
-              <a:srgbClr val="C3E88D"/>
+              <a:srgbClr val="4D7C0F"/>
             </a:solidFill>
           </a:ln>
         </p:spPr>
         <p:style>
-          <a:lnRef idx="2">
+          <a:lnRef idx="1">
             <a:schemeClr val="accent1"/>
           </a:lnRef>
-          <a:fillRef idx="0">
+          <a:fillRef idx="3">
             <a:schemeClr val="accent1"/>
           </a:fillRef>
-          <a:effectRef idx="1">
+          <a:effectRef idx="2">
             <a:schemeClr val="accent1"/>
           </a:effectRef>
           <a:fontRef idx="minor">
-            <a:schemeClr val="tx1"/>
+            <a:schemeClr val="lt1"/>
           </a:fontRef>
         </p:style>
-      </p:cxnSp>
+        <p:txBody>
+          <a:bodyPr rtlCol="0" anchor="ctr" wrap="square" tIns="91440"/>
+          <a:lstStyle/>
+          <a:p>
+            <a:pPr algn="ctr">
+              <a:defRPr sz="1300" b="1">
+                <a:solidFill>
+                  <a:srgbClr val="0F172A"/>
+                </a:solidFill>
+                <a:latin typeface="IBM Plex Mono"/>
+              </a:defRPr>
+            </a:pPr>
+            <a:r>
+              <a:t>09 · PATCH</a:t>
+            </a:r>
+          </a:p>
+          <a:p>
+            <a:pPr>
+              <a:defRPr sz="950">
+                <a:solidFill>
+                  <a:srgbClr val="94A3B8"/>
+                </a:solidFill>
+                <a:latin typeface="IBM Plex Mono"/>
+              </a:defRPr>
+            </a:pPr>
+            <a:r>
+              <a:t>contract.update</a:t>
+            </a:r>
+          </a:p>
+        </p:txBody>
+      </p:sp>
       <p:cxnSp>
         <p:nvCxnSpPr>
           <p:cNvPr id="16" name="Connector 15"/>
@@ -5690,16 +5979,16 @@
           <p:nvPr/>
         </p:nvCxnSpPr>
         <p:spPr>
-          <a:xfrm flipV="1">
-            <a:off x="4663440" y="1691640"/>
-            <a:ext cx="502920" cy="411480"/>
+          <a:xfrm>
+            <a:off x="2423160" y="2468880"/>
+            <a:ext cx="502920" cy="0"/>
           </a:xfrm>
           <a:prstGeom prst="line">
             <a:avLst/>
           </a:prstGeom>
           <a:ln w="19050">
             <a:solidFill>
-              <a:srgbClr val="C3E88D"/>
+              <a:srgbClr val="4D7C0F"/>
             </a:solidFill>
           </a:ln>
         </p:spPr>
@@ -5725,16 +6014,16 @@
           <p:nvPr/>
         </p:nvCxnSpPr>
         <p:spPr>
-          <a:xfrm>
+          <a:xfrm flipV="1">
             <a:off x="4663440" y="2103120"/>
-            <a:ext cx="502920" cy="411480"/>
+            <a:ext cx="502920" cy="365760"/>
           </a:xfrm>
           <a:prstGeom prst="line">
             <a:avLst/>
           </a:prstGeom>
           <a:ln w="19050">
             <a:solidFill>
-              <a:srgbClr val="C3E88D"/>
+              <a:srgbClr val="4D7C0F"/>
             </a:solidFill>
           </a:ln>
         </p:spPr>
@@ -5761,7 +6050,7 @@
         </p:nvCxnSpPr>
         <p:spPr>
           <a:xfrm>
-            <a:off x="6903720" y="1691640"/>
+            <a:off x="4663440" y="2468880"/>
             <a:ext cx="502920" cy="411480"/>
           </a:xfrm>
           <a:prstGeom prst="line">
@@ -5769,7 +6058,7 @@
           </a:prstGeom>
           <a:ln w="19050">
             <a:solidFill>
-              <a:srgbClr val="7DD8C6"/>
+              <a:srgbClr val="4D7C0F"/>
             </a:solidFill>
           </a:ln>
         </p:spPr>
@@ -5795,16 +6084,16 @@
           <p:nvPr/>
         </p:nvCxnSpPr>
         <p:spPr>
-          <a:xfrm flipV="1">
+          <a:xfrm>
             <a:off x="6903720" y="2103120"/>
-            <a:ext cx="502920" cy="411480"/>
+            <a:ext cx="502920" cy="365760"/>
           </a:xfrm>
           <a:prstGeom prst="line">
             <a:avLst/>
           </a:prstGeom>
           <a:ln w="19050">
             <a:solidFill>
-              <a:srgbClr val="7DD8C6"/>
+              <a:srgbClr val="0F766E"/>
             </a:solidFill>
           </a:ln>
         </p:spPr>
@@ -5830,16 +6119,16 @@
           <p:nvPr/>
         </p:nvCxnSpPr>
         <p:spPr>
-          <a:xfrm>
-            <a:off x="8275320" y="2560320"/>
-            <a:ext cx="0" cy="1097280"/>
+          <a:xfrm flipV="1">
+            <a:off x="6903720" y="2468880"/>
+            <a:ext cx="502920" cy="411480"/>
           </a:xfrm>
           <a:prstGeom prst="line">
             <a:avLst/>
           </a:prstGeom>
           <a:ln w="19050">
             <a:solidFill>
-              <a:srgbClr val="7DD8C6"/>
+              <a:srgbClr val="0F766E"/>
             </a:solidFill>
           </a:ln>
         </p:spPr>
@@ -5865,16 +6154,16 @@
           <p:nvPr/>
         </p:nvCxnSpPr>
         <p:spPr>
-          <a:xfrm flipH="1">
-            <a:off x="6903720" y="4114800"/>
-            <a:ext cx="502920" cy="0"/>
+          <a:xfrm>
+            <a:off x="8275320" y="2926080"/>
+            <a:ext cx="0" cy="1005840"/>
           </a:xfrm>
           <a:prstGeom prst="line">
             <a:avLst/>
           </a:prstGeom>
           <a:ln w="19050">
             <a:solidFill>
-              <a:srgbClr val="7DD8C6"/>
+              <a:srgbClr val="0F766E"/>
             </a:solidFill>
           </a:ln>
         </p:spPr>
@@ -5901,7 +6190,7 @@
         </p:nvCxnSpPr>
         <p:spPr>
           <a:xfrm flipH="1">
-            <a:off x="4663440" y="4114800"/>
+            <a:off x="6903720" y="4389120"/>
             <a:ext cx="502920" cy="0"/>
           </a:xfrm>
           <a:prstGeom prst="line">
@@ -5909,7 +6198,7 @@
           </a:prstGeom>
           <a:ln w="19050">
             <a:solidFill>
-              <a:srgbClr val="7DD8C6"/>
+              <a:srgbClr val="0F766E"/>
             </a:solidFill>
           </a:ln>
         </p:spPr>
@@ -5936,7 +6225,7 @@
         </p:nvCxnSpPr>
         <p:spPr>
           <a:xfrm flipH="1">
-            <a:off x="2423160" y="4114800"/>
+            <a:off x="4663440" y="4389120"/>
             <a:ext cx="502920" cy="0"/>
           </a:xfrm>
           <a:prstGeom prst="line">
@@ -5944,7 +6233,7 @@
           </a:prstGeom>
           <a:ln w="19050">
             <a:solidFill>
-              <a:srgbClr val="F4B860"/>
+              <a:srgbClr val="0F766E"/>
             </a:solidFill>
           </a:ln>
         </p:spPr>
@@ -5970,16 +6259,16 @@
           <p:nvPr/>
         </p:nvCxnSpPr>
         <p:spPr>
-          <a:xfrm flipV="1">
-            <a:off x="1554480" y="2560320"/>
-            <a:ext cx="0" cy="1097280"/>
+          <a:xfrm flipH="1">
+            <a:off x="2423160" y="4389120"/>
+            <a:ext cx="502920" cy="0"/>
           </a:xfrm>
           <a:prstGeom prst="line">
             <a:avLst/>
           </a:prstGeom>
           <a:ln w="19050">
             <a:solidFill>
-              <a:srgbClr val="C3E88D"/>
+              <a:srgbClr val="B45309"/>
             </a:solidFill>
           </a:ln>
         </p:spPr>
@@ -5998,91 +6287,23 @@
           </a:fontRef>
         </p:style>
       </p:cxnSp>
-      <p:sp>
-        <p:nvSpPr>
-          <p:cNvPr id="25" name="TextBox 24"/>
-          <p:cNvSpPr txBox="1"/>
-          <p:nvPr/>
-        </p:nvSpPr>
-        <p:spPr>
-          <a:xfrm>
-            <a:off x="685800" y="4846320"/>
-            <a:ext cx="10817352" cy="1097280"/>
-          </a:xfrm>
-          <a:prstGeom prst="rect">
-            <a:avLst/>
-          </a:prstGeom>
-          <a:noFill/>
-        </p:spPr>
-        <p:txBody>
-          <a:bodyPr wrap="square" lIns="0" rIns="0" tIns="0" bIns="0">
-            <a:spAutoFit/>
-          </a:bodyPr>
-          <a:lstStyle/>
-          <a:p>
-            <a:pPr>
-              <a:spcAft>
-                <a:spcPts val="600"/>
-              </a:spcAft>
-            </a:pPr>
-            <a:r>
-              <a:rPr b="1" sz="1300">
-                <a:solidFill>
-                  <a:srgbClr val="7DD8C6"/>
-                </a:solidFill>
-                <a:latin typeface="IBM Plex Mono"/>
-              </a:rPr>
-              <a:t>· Forward Pass: </a:t>
-            </a:r>
-            <a:r>
-              <a:rPr sz="1300">
-                <a:solidFill>
-                  <a:srgbClr val="E8E4D4"/>
-                </a:solidFill>
-                <a:latin typeface="Arial"/>
-              </a:rPr>
-              <a:t>도구 스펙 Catalog 분석 → 데이터 합성(01) → 소형 모델 파인튜닝(02) → 다양한 벤치마크 평가(03,04) → Trace 수집(05) 단계로 순차 실행.</a:t>
-            </a:r>
-          </a:p>
-          <a:p>
-            <a:r>
-              <a:rPr b="1" sz="1300">
-                <a:solidFill>
-                  <a:srgbClr val="F4B860"/>
-                </a:solidFill>
-                <a:latin typeface="IBM Plex Mono"/>
-              </a:rPr>
-              <a:t>· Feedback Loop: </a:t>
-            </a:r>
-            <a:r>
-              <a:rPr sz="1300">
-                <a:solidFill>
-                  <a:srgbClr val="E8E4D4"/>
-                </a:solidFill>
-                <a:latin typeface="Arial"/>
-              </a:rPr>
-              <a:t>에러 로그 분류(06) → 성능 통계 분석(07) → Myelin Compiler 컴파일 패스 규칙 도출(08) → 툴 계약 패치(09)의 순환 복구 구조를 가짐.</a:t>
-            </a:r>
-          </a:p>
-        </p:txBody>
-      </p:sp>
       <p:cxnSp>
         <p:nvCxnSpPr>
-          <p:cNvPr id="26" name="Connector 25"/>
+          <p:cNvPr id="25" name="Connector 24"/>
           <p:cNvCxnSpPr/>
           <p:nvPr/>
         </p:nvCxnSpPr>
         <p:spPr>
-          <a:xfrm>
-            <a:off x="685800" y="6126480"/>
-            <a:ext cx="10817352" cy="0"/>
+          <a:xfrm flipV="1">
+            <a:off x="1554480" y="2926080"/>
+            <a:ext cx="0" cy="1005840"/>
           </a:xfrm>
           <a:prstGeom prst="line">
             <a:avLst/>
           </a:prstGeom>
           <a:ln w="19050">
             <a:solidFill>
-              <a:srgbClr val="2A2A26"/>
+              <a:srgbClr val="4D7C0F"/>
             </a:solidFill>
           </a:ln>
         </p:spPr>
@@ -6103,14 +6324,14 @@
       </p:cxnSp>
       <p:sp>
         <p:nvSpPr>
-          <p:cNvPr id="27" name="TextBox 26"/>
+          <p:cNvPr id="26" name="TextBox 25"/>
           <p:cNvSpPr txBox="1"/>
           <p:nvPr/>
         </p:nvSpPr>
         <p:spPr>
           <a:xfrm>
-            <a:off x="685800" y="6263640"/>
-            <a:ext cx="5486400" cy="365760"/>
+            <a:off x="685800" y="5074920"/>
+            <a:ext cx="10817352" cy="914400"/>
           </a:xfrm>
           <a:prstGeom prst="rect">
             <a:avLst/>
@@ -6124,19 +6345,86 @@
           <a:lstStyle/>
           <a:p>
             <a:pPr>
-              <a:defRPr sz="1000">
-                <a:solidFill>
-                  <a:srgbClr val="5C564B"/>
-                </a:solidFill>
-                <a:latin typeface="IBM Plex Mono"/>
-              </a:defRPr>
-            </a:pPr>
-            <a:r>
-              <a:t>GANGLION // SYSTEMS CO-DESIGN</a:t>
-            </a:r>
-          </a:p>
-        </p:txBody>
-      </p:sp>
+              <a:spcAft>
+                <a:spcPts val="500"/>
+              </a:spcAft>
+            </a:pPr>
+            <a:r>
+              <a:rPr b="1" sz="1250">
+                <a:solidFill>
+                  <a:srgbClr val="0F766E"/>
+                </a:solidFill>
+                <a:latin typeface="IBM Plex Mono"/>
+              </a:rPr>
+              <a:t>· Forward Pass: </a:t>
+            </a:r>
+            <a:r>
+              <a:rPr sz="1250">
+                <a:solidFill>
+                  <a:srgbClr val="334155"/>
+                </a:solidFill>
+                <a:latin typeface="Arial"/>
+              </a:rPr>
+              <a:t>도구 스펙 Catalog 분석 → 데이터 합성(01) → 소형 모델 파인튜닝(02) → 다양한 벤치마크 평가(03,04) → Trace 수집(05) 단계로 순차 실행.</a:t>
+            </a:r>
+          </a:p>
+          <a:p>
+            <a:r>
+              <a:rPr b="1" sz="1250">
+                <a:solidFill>
+                  <a:srgbClr val="B45309"/>
+                </a:solidFill>
+                <a:latin typeface="IBM Plex Mono"/>
+              </a:rPr>
+              <a:t>· Feedback Loop: </a:t>
+            </a:r>
+            <a:r>
+              <a:rPr sz="1250">
+                <a:solidFill>
+                  <a:srgbClr val="334155"/>
+                </a:solidFill>
+                <a:latin typeface="Arial"/>
+              </a:rPr>
+              <a:t>에러 로그 분류(06) → 성능 통계 분석(07) → Myelin Compiler 컴파일 패스 규칙 도출(08) → 툴 계약 패치(09)의 순환 복구 구조를 가짐.</a:t>
+            </a:r>
+          </a:p>
+        </p:txBody>
+      </p:sp>
+      <p:cxnSp>
+        <p:nvCxnSpPr>
+          <p:cNvPr id="27" name="Connector 26"/>
+          <p:cNvCxnSpPr/>
+          <p:nvPr/>
+        </p:nvCxnSpPr>
+        <p:spPr>
+          <a:xfrm>
+            <a:off x="685800" y="6126480"/>
+            <a:ext cx="10817352" cy="0"/>
+          </a:xfrm>
+          <a:prstGeom prst="line">
+            <a:avLst/>
+          </a:prstGeom>
+          <a:ln w="12700">
+            <a:solidFill>
+              <a:srgbClr val="E2E8F0"/>
+            </a:solidFill>
+          </a:ln>
+        </p:spPr>
+        <p:style>
+          <a:lnRef idx="2">
+            <a:schemeClr val="accent1"/>
+          </a:lnRef>
+          <a:fillRef idx="0">
+            <a:schemeClr val="accent1"/>
+          </a:fillRef>
+          <a:effectRef idx="1">
+            <a:schemeClr val="accent1"/>
+          </a:effectRef>
+          <a:fontRef idx="minor">
+            <a:schemeClr val="tx1"/>
+          </a:fontRef>
+        </p:style>
+      </p:cxnSp>
       <p:sp>
         <p:nvSpPr>
           <p:cNvPr id="28" name="TextBox 27"/>
@@ -6145,8 +6433,8 @@
         </p:nvSpPr>
         <p:spPr>
           <a:xfrm>
-            <a:off x="8686800" y="6263640"/>
-            <a:ext cx="2816352" cy="365760"/>
+            <a:off x="685800" y="6263640"/>
+            <a:ext cx="5486400" cy="365760"/>
           </a:xfrm>
           <a:prstGeom prst="rect">
             <a:avLst/>
@@ -6159,10 +6447,46 @@
           </a:bodyPr>
           <a:lstStyle/>
           <a:p>
+            <a:pPr>
+              <a:defRPr sz="1000">
+                <a:solidFill>
+                  <a:srgbClr val="94A3B8"/>
+                </a:solidFill>
+                <a:latin typeface="IBM Plex Mono"/>
+              </a:defRPr>
+            </a:pPr>
+            <a:r>
+              <a:t>GANGLION // SYSTEMS CO-DESIGN</a:t>
+            </a:r>
+          </a:p>
+        </p:txBody>
+      </p:sp>
+      <p:sp>
+        <p:nvSpPr>
+          <p:cNvPr id="29" name="TextBox 28"/>
+          <p:cNvSpPr txBox="1"/>
+          <p:nvPr/>
+        </p:nvSpPr>
+        <p:spPr>
+          <a:xfrm>
+            <a:off x="8686800" y="6263640"/>
+            <a:ext cx="2816352" cy="365760"/>
+          </a:xfrm>
+          <a:prstGeom prst="rect">
+            <a:avLst/>
+          </a:prstGeom>
+          <a:noFill/>
+        </p:spPr>
+        <p:txBody>
+          <a:bodyPr wrap="square" lIns="0" rIns="0" tIns="0" bIns="0">
+            <a:spAutoFit/>
+          </a:bodyPr>
+          <a:lstStyle/>
+          <a:p>
             <a:pPr algn="r">
               <a:defRPr sz="1000">
                 <a:solidFill>
-                  <a:srgbClr val="5C564B"/>
+                  <a:srgbClr val="94A3B8"/>
                 </a:solidFill>
                 <a:latin typeface="IBM Plex Mono"/>
               </a:defRPr>
@@ -6187,7 +6511,7 @@
     <p:bg>
       <p:bgPr>
         <a:solidFill>
-          <a:srgbClr val="0E0E0C"/>
+          <a:srgbClr val="FFFFFF"/>
         </a:solidFill>
         <a:effectLst/>
       </p:bgPr>
@@ -6224,7 +6548,7 @@
             <a:pPr>
               <a:defRPr sz="1000" b="1">
                 <a:solidFill>
-                  <a:srgbClr val="7DD8C6"/>
+                  <a:srgbClr val="0F766E"/>
                 </a:solidFill>
                 <a:latin typeface="IBM Plex Mono"/>
               </a:defRPr>
@@ -6260,7 +6584,7 @@
             <a:pPr>
               <a:defRPr sz="2400" b="1">
                 <a:solidFill>
-                  <a:srgbClr val="FFFCF0"/>
+                  <a:srgbClr val="0F172A"/>
                 </a:solidFill>
                 <a:latin typeface="IBM Plex Mono"/>
               </a:defRPr>
@@ -6296,7 +6620,7 @@
             <a:pPr algn="r">
               <a:defRPr sz="1100">
                 <a:solidFill>
-                  <a:srgbClr val="5C564B"/>
+                  <a:srgbClr val="94A3B8"/>
                 </a:solidFill>
                 <a:latin typeface="IBM Plex Mono"/>
               </a:defRPr>
@@ -6321,9 +6645,9 @@
           <a:prstGeom prst="line">
             <a:avLst/>
           </a:prstGeom>
-          <a:ln w="19050">
+          <a:ln w="12700">
             <a:solidFill>
-              <a:srgbClr val="2A2A26"/>
+              <a:srgbClr val="E2E8F0"/>
             </a:solidFill>
           </a:ln>
         </p:spPr>
@@ -6350,17 +6674,19 @@
         </p:nvSpPr>
         <p:spPr>
           <a:xfrm>
-            <a:off x="685800" y="1463040"/>
-            <a:ext cx="73152" cy="1188720"/>
+            <a:off x="685800" y="1280160"/>
+            <a:ext cx="10817352" cy="411480"/>
           </a:xfrm>
           <a:prstGeom prst="rect">
             <a:avLst/>
           </a:prstGeom>
           <a:solidFill>
-            <a:srgbClr val="C3E88D"/>
+            <a:srgbClr val="F1F5F9"/>
           </a:solidFill>
-          <a:ln>
-            <a:noFill/>
+          <a:ln w="9525">
+            <a:solidFill>
+              <a:srgbClr val="4D7C0F"/>
+            </a:solidFill>
           </a:ln>
         </p:spPr>
         <p:style>
@@ -6378,6 +6704,101 @@
           </a:fontRef>
         </p:style>
         <p:txBody>
+          <a:bodyPr rtlCol="0" anchor="ctr" wrap="square" lIns="164592" rIns="164592" bIns="36576"/>
+          <a:lstStyle/>
+          <a:p>
+            <a:pPr algn="ctr"/>
+            <a:r>
+              <a:rPr sz="850" b="1">
+                <a:solidFill>
+                  <a:srgbClr val="4D7C0F"/>
+                </a:solidFill>
+                <a:latin typeface="IBM Plex Mono"/>
+              </a:rPr>
+              <a:t>EXAMPLE · STAGE 01 · SYNTH → GOLD PAIR</a:t>
+            </a:r>
+            <a:r>
+              <a:rPr sz="850">
+                <a:solidFill>
+                  <a:srgbClr val="94A3B8"/>
+                </a:solidFill>
+                <a:latin typeface="IBM Plex Mono"/>
+              </a:rPr>
+              <a:t>    USER INPUT → </a:t>
+            </a:r>
+            <a:r>
+              <a:rPr sz="850" i="1">
+                <a:solidFill>
+                  <a:srgbClr val="64748B"/>
+                </a:solidFill>
+                <a:latin typeface="IBM Plex Mono"/>
+              </a:rPr>
+              <a:t>“거실 조명을 50%로 켜줘”</a:t>
+            </a:r>
+          </a:p>
+          <a:p>
+            <a:pPr>
+              <a:spcBef>
+                <a:spcPts val="100"/>
+              </a:spcBef>
+            </a:pPr>
+            <a:r>
+              <a:rPr sz="1000" b="1">
+                <a:solidFill>
+                  <a:srgbClr val="4D7C0F"/>
+                </a:solidFill>
+                <a:latin typeface="IBM Plex Mono"/>
+              </a:rPr>
+              <a:t>▸  </a:t>
+            </a:r>
+            <a:r>
+              <a:rPr sz="1000" b="1">
+                <a:solidFill>
+                  <a:srgbClr val="0F172A"/>
+                </a:solidFill>
+                <a:latin typeface="IBM Plex Mono"/>
+              </a:rPr>
+              <a:t>Pair{ prompt:"거실 조명을 50%로 켜줘",  gold:{calls:[{tool:"set_light",args:{room:"living",level:50}}]} }</a:t>
+            </a:r>
+          </a:p>
+        </p:txBody>
+      </p:sp>
+      <p:sp>
+        <p:nvSpPr>
+          <p:cNvPr id="7" name="Rectangle 6"/>
+          <p:cNvSpPr/>
+          <p:nvPr/>
+        </p:nvSpPr>
+        <p:spPr>
+          <a:xfrm>
+            <a:off x="685800" y="1783080"/>
+            <a:ext cx="73152" cy="1143000"/>
+          </a:xfrm>
+          <a:prstGeom prst="rect">
+            <a:avLst/>
+          </a:prstGeom>
+          <a:solidFill>
+            <a:srgbClr val="4D7C0F"/>
+          </a:solidFill>
+          <a:ln>
+            <a:noFill/>
+          </a:ln>
+        </p:spPr>
+        <p:style>
+          <a:lnRef idx="1">
+            <a:schemeClr val="accent1"/>
+          </a:lnRef>
+          <a:fillRef idx="3">
+            <a:schemeClr val="accent1"/>
+          </a:fillRef>
+          <a:effectRef idx="2">
+            <a:schemeClr val="accent1"/>
+          </a:effectRef>
+          <a:fontRef idx="minor">
+            <a:schemeClr val="lt1"/>
+          </a:fontRef>
+        </p:style>
+        <p:txBody>
           <a:bodyPr rtlCol="0" anchor="ctr"/>
           <a:lstStyle/>
           <a:p>
@@ -6387,14 +6808,14 @@
       </p:sp>
       <p:sp>
         <p:nvSpPr>
-          <p:cNvPr id="7" name="TextBox 6"/>
+          <p:cNvPr id="8" name="TextBox 7"/>
           <p:cNvSpPr txBox="1"/>
           <p:nvPr/>
         </p:nvSpPr>
         <p:spPr>
           <a:xfrm>
-            <a:off x="914400" y="1463040"/>
-            <a:ext cx="10588752" cy="1188720"/>
+            <a:off x="914400" y="1783080"/>
+            <a:ext cx="10588752" cy="1143000"/>
           </a:xfrm>
           <a:prstGeom prst="rect">
             <a:avLst/>
@@ -6413,7 +6834,7 @@
               </a:spcAft>
               <a:defRPr sz="1700" b="1">
                 <a:solidFill>
-                  <a:srgbClr val="FFFCF0"/>
+                  <a:srgbClr val="0F172A"/>
                 </a:solidFill>
                 <a:latin typeface="IBM Plex Mono"/>
               </a:defRPr>
@@ -6426,7 +6847,7 @@
             <a:pPr>
               <a:defRPr sz="1300">
                 <a:solidFill>
-                  <a:srgbClr val="9A9485"/>
+                  <a:srgbClr val="64748B"/>
                 </a:solidFill>
                 <a:latin typeface="Arial"/>
               </a:defRPr>
@@ -6439,20 +6860,20 @@
       </p:sp>
       <p:sp>
         <p:nvSpPr>
-          <p:cNvPr id="8" name="Rectangle 7"/>
+          <p:cNvPr id="9" name="Rectangle 8"/>
           <p:cNvSpPr/>
           <p:nvPr/>
         </p:nvSpPr>
         <p:spPr>
           <a:xfrm>
-            <a:off x="685800" y="2926080"/>
-            <a:ext cx="73152" cy="1188720"/>
+            <a:off x="685800" y="3154680"/>
+            <a:ext cx="73152" cy="1143000"/>
           </a:xfrm>
           <a:prstGeom prst="rect">
             <a:avLst/>
           </a:prstGeom>
           <a:solidFill>
-            <a:srgbClr val="C3E88D"/>
+            <a:srgbClr val="4D7C0F"/>
           </a:solidFill>
           <a:ln>
             <a:noFill/>
@@ -6482,14 +6903,14 @@
       </p:sp>
       <p:sp>
         <p:nvSpPr>
-          <p:cNvPr id="9" name="TextBox 8"/>
+          <p:cNvPr id="10" name="TextBox 9"/>
           <p:cNvSpPr txBox="1"/>
           <p:nvPr/>
         </p:nvSpPr>
         <p:spPr>
           <a:xfrm>
-            <a:off x="914400" y="2926080"/>
-            <a:ext cx="10588752" cy="1188720"/>
+            <a:off x="914400" y="3154680"/>
+            <a:ext cx="10588752" cy="1143000"/>
           </a:xfrm>
           <a:prstGeom prst="rect">
             <a:avLst/>
@@ -6508,7 +6929,7 @@
               </a:spcAft>
               <a:defRPr sz="1700" b="1">
                 <a:solidFill>
-                  <a:srgbClr val="FFFCF0"/>
+                  <a:srgbClr val="0F172A"/>
                 </a:solidFill>
                 <a:latin typeface="IBM Plex Mono"/>
               </a:defRPr>
@@ -6521,7 +6942,7 @@
             <a:pPr>
               <a:defRPr sz="1300">
                 <a:solidFill>
-                  <a:srgbClr val="9A9485"/>
+                  <a:srgbClr val="64748B"/>
                 </a:solidFill>
                 <a:latin typeface="Arial"/>
               </a:defRPr>
@@ -6534,20 +6955,20 @@
       </p:sp>
       <p:sp>
         <p:nvSpPr>
-          <p:cNvPr id="10" name="Rectangle 9"/>
+          <p:cNvPr id="11" name="Rectangle 10"/>
           <p:cNvSpPr/>
           <p:nvPr/>
         </p:nvSpPr>
         <p:spPr>
           <a:xfrm>
-            <a:off x="685800" y="4389120"/>
-            <a:ext cx="73152" cy="1188720"/>
+            <a:off x="685800" y="4526280"/>
+            <a:ext cx="73152" cy="1143000"/>
           </a:xfrm>
           <a:prstGeom prst="rect">
             <a:avLst/>
           </a:prstGeom>
           <a:solidFill>
-            <a:srgbClr val="C3E88D"/>
+            <a:srgbClr val="4D7C0F"/>
           </a:solidFill>
           <a:ln>
             <a:noFill/>
@@ -6577,14 +6998,14 @@
       </p:sp>
       <p:sp>
         <p:nvSpPr>
-          <p:cNvPr id="11" name="TextBox 10"/>
+          <p:cNvPr id="12" name="TextBox 11"/>
           <p:cNvSpPr txBox="1"/>
           <p:nvPr/>
         </p:nvSpPr>
         <p:spPr>
           <a:xfrm>
-            <a:off x="914400" y="4389120"/>
-            <a:ext cx="10588752" cy="1188720"/>
+            <a:off x="914400" y="4526280"/>
+            <a:ext cx="10588752" cy="1143000"/>
           </a:xfrm>
           <a:prstGeom prst="rect">
             <a:avLst/>
@@ -6603,7 +7024,7 @@
               </a:spcAft>
               <a:defRPr sz="1700" b="1">
                 <a:solidFill>
-                  <a:srgbClr val="FFFCF0"/>
+                  <a:srgbClr val="0F172A"/>
                 </a:solidFill>
                 <a:latin typeface="IBM Plex Mono"/>
               </a:defRPr>
@@ -6616,7 +7037,7 @@
             <a:pPr>
               <a:defRPr sz="1300">
                 <a:solidFill>
-                  <a:srgbClr val="9A9485"/>
+                  <a:srgbClr val="64748B"/>
                 </a:solidFill>
                 <a:latin typeface="Arial"/>
               </a:defRPr>
@@ -6629,7 +7050,7 @@
       </p:sp>
       <p:cxnSp>
         <p:nvCxnSpPr>
-          <p:cNvPr id="12" name="Connector 11"/>
+          <p:cNvPr id="13" name="Connector 12"/>
           <p:cNvCxnSpPr/>
           <p:nvPr/>
         </p:nvCxnSpPr>
@@ -6641,9 +7062,9 @@
           <a:prstGeom prst="line">
             <a:avLst/>
           </a:prstGeom>
-          <a:ln w="19050">
+          <a:ln w="12700">
             <a:solidFill>
-              <a:srgbClr val="2A2A26"/>
+              <a:srgbClr val="E2E8F0"/>
             </a:solidFill>
           </a:ln>
         </p:spPr>
@@ -6664,7 +7085,7 @@
       </p:cxnSp>
       <p:sp>
         <p:nvSpPr>
-          <p:cNvPr id="13" name="TextBox 12"/>
+          <p:cNvPr id="14" name="TextBox 13"/>
           <p:cNvSpPr txBox="1"/>
           <p:nvPr/>
         </p:nvSpPr>
@@ -6687,7 +7108,7 @@
             <a:pPr>
               <a:defRPr sz="1000">
                 <a:solidFill>
-                  <a:srgbClr val="5C564B"/>
+                  <a:srgbClr val="94A3B8"/>
                 </a:solidFill>
                 <a:latin typeface="IBM Plex Mono"/>
               </a:defRPr>
@@ -6700,7 +7121,7 @@
       </p:sp>
       <p:sp>
         <p:nvSpPr>
-          <p:cNvPr id="14" name="TextBox 13"/>
+          <p:cNvPr id="15" name="TextBox 14"/>
           <p:cNvSpPr txBox="1"/>
           <p:nvPr/>
         </p:nvSpPr>
@@ -6723,7 +7144,7 @@
             <a:pPr algn="r">
               <a:defRPr sz="1000">
                 <a:solidFill>
-                  <a:srgbClr val="5C564B"/>
+                  <a:srgbClr val="94A3B8"/>
                 </a:solidFill>
                 <a:latin typeface="IBM Plex Mono"/>
               </a:defRPr>
@@ -6748,7 +7169,7 @@
     <p:bg>
       <p:bgPr>
         <a:solidFill>
-          <a:srgbClr val="0E0E0C"/>
+          <a:srgbClr val="FFFFFF"/>
         </a:solidFill>
         <a:effectLst/>
       </p:bgPr>
@@ -6785,7 +7206,7 @@
             <a:pPr>
               <a:defRPr sz="1000" b="1">
                 <a:solidFill>
-                  <a:srgbClr val="7DD8C6"/>
+                  <a:srgbClr val="0F766E"/>
                 </a:solidFill>
                 <a:latin typeface="IBM Plex Mono"/>
               </a:defRPr>
@@ -6821,7 +7242,7 @@
             <a:pPr>
               <a:defRPr sz="2400" b="1">
                 <a:solidFill>
-                  <a:srgbClr val="FFFCF0"/>
+                  <a:srgbClr val="0F172A"/>
                 </a:solidFill>
                 <a:latin typeface="IBM Plex Mono"/>
               </a:defRPr>
@@ -6857,7 +7278,7 @@
             <a:pPr algn="r">
               <a:defRPr sz="1100">
                 <a:solidFill>
-                  <a:srgbClr val="5C564B"/>
+                  <a:srgbClr val="94A3B8"/>
                 </a:solidFill>
                 <a:latin typeface="IBM Plex Mono"/>
               </a:defRPr>
@@ -6882,9 +7303,9 @@
           <a:prstGeom prst="line">
             <a:avLst/>
           </a:prstGeom>
-          <a:ln w="19050">
+          <a:ln w="12700">
             <a:solidFill>
-              <a:srgbClr val="2A2A26"/>
+              <a:srgbClr val="E2E8F0"/>
             </a:solidFill>
           </a:ln>
         </p:spPr>
@@ -6911,18 +7332,18 @@
         </p:nvSpPr>
         <p:spPr>
           <a:xfrm>
-            <a:off x="685800" y="1463040"/>
-            <a:ext cx="5303520" cy="4297680"/>
+            <a:off x="685800" y="1280160"/>
+            <a:ext cx="10817352" cy="411480"/>
           </a:xfrm>
           <a:prstGeom prst="rect">
             <a:avLst/>
           </a:prstGeom>
           <a:solidFill>
-            <a:srgbClr val="181814"/>
+            <a:srgbClr val="F1F5F9"/>
           </a:solidFill>
-          <a:ln w="19050">
+          <a:ln w="9525">
             <a:solidFill>
-              <a:srgbClr val="3D3D36"/>
+              <a:srgbClr val="B45309"/>
             </a:solidFill>
           </a:ln>
         </p:spPr>
@@ -6941,16 +7362,113 @@
           </a:fontRef>
         </p:style>
         <p:txBody>
-          <a:bodyPr rtlCol="0" anchor="ctr" wrap="square" lIns="274320" rIns="274320" tIns="274320"/>
+          <a:bodyPr rtlCol="0" anchor="ctr" wrap="square" lIns="164592" rIns="164592" bIns="36576"/>
+          <a:lstStyle/>
+          <a:p>
+            <a:pPr algn="ctr"/>
+            <a:r>
+              <a:rPr sz="850" b="1">
+                <a:solidFill>
+                  <a:srgbClr val="B45309"/>
+                </a:solidFill>
+                <a:latin typeface="IBM Plex Mono"/>
+              </a:rPr>
+              <a:t>EXAMPLE · STAGE · GRAMMAR MASK + POST-CORRECT</a:t>
+            </a:r>
+            <a:r>
+              <a:rPr sz="850">
+                <a:solidFill>
+                  <a:srgbClr val="94A3B8"/>
+                </a:solidFill>
+                <a:latin typeface="IBM Plex Mono"/>
+              </a:rPr>
+              <a:t>    USER INPUT → </a:t>
+            </a:r>
+            <a:r>
+              <a:rPr sz="850" i="1">
+                <a:solidFill>
+                  <a:srgbClr val="64748B"/>
+                </a:solidFill>
+                <a:latin typeface="IBM Plex Mono"/>
+              </a:rPr>
+              <a:t>“거실 조명을 50%로 켜줘”</a:t>
+            </a:r>
+          </a:p>
+          <a:p>
+            <a:pPr>
+              <a:spcBef>
+                <a:spcPts val="100"/>
+              </a:spcBef>
+            </a:pPr>
+            <a:r>
+              <a:rPr sz="1000" b="1">
+                <a:solidFill>
+                  <a:srgbClr val="B45309"/>
+                </a:solidFill>
+                <a:latin typeface="IBM Plex Mono"/>
+              </a:rPr>
+              <a:t>▸  </a:t>
+            </a:r>
+            <a:r>
+              <a:rPr sz="1000" b="1">
+                <a:solidFill>
+                  <a:srgbClr val="0F172A"/>
+                </a:solidFill>
+                <a:latin typeface="IBM Plex Mono"/>
+              </a:rPr>
+              <a:t>raw {tool:"set_light", args:{room:"거실"}}   →   alias(거실→living) + default(level=100)   →   fixed IR</a:t>
+            </a:r>
+          </a:p>
+        </p:txBody>
+      </p:sp>
+      <p:sp>
+        <p:nvSpPr>
+          <p:cNvPr id="7" name="Rectangle 6"/>
+          <p:cNvSpPr/>
+          <p:nvPr/>
+        </p:nvSpPr>
+        <p:spPr>
+          <a:xfrm>
+            <a:off x="685800" y="1783080"/>
+            <a:ext cx="5303520" cy="4023360"/>
+          </a:xfrm>
+          <a:prstGeom prst="rect">
+            <a:avLst/>
+          </a:prstGeom>
+          <a:solidFill>
+            <a:srgbClr val="F8FAFC"/>
+          </a:solidFill>
+          <a:ln w="12700">
+            <a:solidFill>
+              <a:srgbClr val="CBD5E1"/>
+            </a:solidFill>
+          </a:ln>
+        </p:spPr>
+        <p:style>
+          <a:lnRef idx="1">
+            <a:schemeClr val="accent1"/>
+          </a:lnRef>
+          <a:fillRef idx="3">
+            <a:schemeClr val="accent1"/>
+          </a:fillRef>
+          <a:effectRef idx="2">
+            <a:schemeClr val="accent1"/>
+          </a:effectRef>
+          <a:fontRef idx="minor">
+            <a:schemeClr val="lt1"/>
+          </a:fontRef>
+        </p:style>
+        <p:txBody>
+          <a:bodyPr rtlCol="0" anchor="t" wrap="square" lIns="274320" rIns="274320" tIns="274320"/>
           <a:lstStyle/>
           <a:p>
             <a:pPr algn="ctr">
               <a:spcAft>
-                <a:spcPts val="2000"/>
+                <a:spcPts val="1800"/>
               </a:spcAft>
               <a:defRPr sz="1800" b="1">
                 <a:solidFill>
-                  <a:srgbClr val="7DD8C6"/>
+                  <a:srgbClr val="0F766E"/>
                 </a:solidFill>
                 <a:latin typeface="IBM Plex Mono"/>
               </a:defRPr>
@@ -6966,7 +7484,7 @@
               </a:spcAft>
               <a:defRPr sz="1450" b="1">
                 <a:solidFill>
-                  <a:srgbClr val="FFFCF0"/>
+                  <a:srgbClr val="0F172A"/>
                 </a:solidFill>
                 <a:latin typeface="IBM Plex Mono"/>
               </a:defRPr>
@@ -6978,11 +7496,11 @@
           <a:p>
             <a:pPr>
               <a:spcAft>
-                <a:spcPts val="1800"/>
+                <a:spcPts val="1600"/>
               </a:spcAft>
               <a:defRPr sz="1300">
                 <a:solidFill>
-                  <a:srgbClr val="9A9485"/>
+                  <a:srgbClr val="64748B"/>
                 </a:solidFill>
                 <a:latin typeface="Arial"/>
               </a:defRPr>
@@ -6998,7 +7516,7 @@
               </a:spcAft>
               <a:defRPr sz="1450" b="1">
                 <a:solidFill>
-                  <a:srgbClr val="FFFCF0"/>
+                  <a:srgbClr val="0F172A"/>
                 </a:solidFill>
                 <a:latin typeface="IBM Plex Mono"/>
               </a:defRPr>
@@ -7011,7 +7529,7 @@
             <a:pPr>
               <a:defRPr sz="1300">
                 <a:solidFill>
-                  <a:srgbClr val="9A9485"/>
+                  <a:srgbClr val="64748B"/>
                 </a:solidFill>
                 <a:latin typeface="Arial"/>
               </a:defRPr>
@@ -7024,24 +7542,24 @@
       </p:sp>
       <p:sp>
         <p:nvSpPr>
-          <p:cNvPr id="7" name="Rectangle 6"/>
+          <p:cNvPr id="8" name="Rectangle 7"/>
           <p:cNvSpPr/>
           <p:nvPr/>
         </p:nvSpPr>
         <p:spPr>
           <a:xfrm>
-            <a:off x="6199632" y="1463040"/>
-            <a:ext cx="5303520" cy="4297680"/>
+            <a:off x="6199632" y="1783080"/>
+            <a:ext cx="5303520" cy="4023360"/>
           </a:xfrm>
           <a:prstGeom prst="rect">
             <a:avLst/>
           </a:prstGeom>
           <a:solidFill>
-            <a:srgbClr val="181814"/>
+            <a:srgbClr val="F8FAFC"/>
           </a:solidFill>
-          <a:ln w="19050">
+          <a:ln w="12700">
             <a:solidFill>
-              <a:srgbClr val="3D3D36"/>
+              <a:srgbClr val="CBD5E1"/>
             </a:solidFill>
           </a:ln>
         </p:spPr>
@@ -7060,16 +7578,16 @@
           </a:fontRef>
         </p:style>
         <p:txBody>
-          <a:bodyPr rtlCol="0" anchor="ctr" wrap="square" lIns="274320" rIns="274320" tIns="274320"/>
+          <a:bodyPr rtlCol="0" anchor="t" wrap="square" lIns="274320" rIns="274320" tIns="274320"/>
           <a:lstStyle/>
           <a:p>
             <a:pPr algn="ctr">
               <a:spcAft>
-                <a:spcPts val="2000"/>
+                <a:spcPts val="1800"/>
               </a:spcAft>
               <a:defRPr sz="1800" b="1">
                 <a:solidFill>
-                  <a:srgbClr val="F4B860"/>
+                  <a:srgbClr val="B45309"/>
                 </a:solidFill>
                 <a:latin typeface="IBM Plex Mono"/>
               </a:defRPr>
@@ -7085,7 +7603,7 @@
               </a:spcAft>
               <a:defRPr sz="1450" b="1">
                 <a:solidFill>
-                  <a:srgbClr val="FFFCF0"/>
+                  <a:srgbClr val="0F172A"/>
                 </a:solidFill>
                 <a:latin typeface="IBM Plex Mono"/>
               </a:defRPr>
@@ -7097,11 +7615,11 @@
           <a:p>
             <a:pPr>
               <a:spcAft>
-                <a:spcPts val="1800"/>
+                <a:spcPts val="1600"/>
               </a:spcAft>
               <a:defRPr sz="1300">
                 <a:solidFill>
-                  <a:srgbClr val="9A9485"/>
+                  <a:srgbClr val="64748B"/>
                 </a:solidFill>
                 <a:latin typeface="Arial"/>
               </a:defRPr>
@@ -7117,7 +7635,7 @@
               </a:spcAft>
               <a:defRPr sz="1450" b="1">
                 <a:solidFill>
-                  <a:srgbClr val="FFFCF0"/>
+                  <a:srgbClr val="0F172A"/>
                 </a:solidFill>
                 <a:latin typeface="IBM Plex Mono"/>
               </a:defRPr>
@@ -7130,7 +7648,7 @@
             <a:pPr>
               <a:defRPr sz="1300">
                 <a:solidFill>
-                  <a:srgbClr val="9A9485"/>
+                  <a:srgbClr val="64748B"/>
                 </a:solidFill>
                 <a:latin typeface="Arial"/>
               </a:defRPr>
@@ -7143,7 +7661,7 @@
       </p:sp>
       <p:cxnSp>
         <p:nvCxnSpPr>
-          <p:cNvPr id="8" name="Connector 7"/>
+          <p:cNvPr id="9" name="Connector 8"/>
           <p:cNvCxnSpPr/>
           <p:nvPr/>
         </p:nvCxnSpPr>
@@ -7155,9 +7673,9 @@
           <a:prstGeom prst="line">
             <a:avLst/>
           </a:prstGeom>
-          <a:ln w="19050">
+          <a:ln w="12700">
             <a:solidFill>
-              <a:srgbClr val="2A2A26"/>
+              <a:srgbClr val="E2E8F0"/>
             </a:solidFill>
           </a:ln>
         </p:spPr>
@@ -7178,7 +7696,7 @@
       </p:cxnSp>
       <p:sp>
         <p:nvSpPr>
-          <p:cNvPr id="9" name="TextBox 8"/>
+          <p:cNvPr id="10" name="TextBox 9"/>
           <p:cNvSpPr txBox="1"/>
           <p:nvPr/>
         </p:nvSpPr>
@@ -7201,7 +7719,7 @@
             <a:pPr>
               <a:defRPr sz="1000">
                 <a:solidFill>
-                  <a:srgbClr val="5C564B"/>
+                  <a:srgbClr val="94A3B8"/>
                 </a:solidFill>
                 <a:latin typeface="IBM Plex Mono"/>
               </a:defRPr>
@@ -7214,7 +7732,7 @@
       </p:sp>
       <p:sp>
         <p:nvSpPr>
-          <p:cNvPr id="10" name="TextBox 9"/>
+          <p:cNvPr id="11" name="TextBox 10"/>
           <p:cNvSpPr txBox="1"/>
           <p:nvPr/>
         </p:nvSpPr>
@@ -7237,7 +7755,7 @@
             <a:pPr algn="r">
               <a:defRPr sz="1000">
                 <a:solidFill>
-                  <a:srgbClr val="5C564B"/>
+                  <a:srgbClr val="94A3B8"/>
                 </a:solidFill>
                 <a:latin typeface="IBM Plex Mono"/>
               </a:defRPr>
@@ -7262,7 +7780,7 @@
     <p:bg>
       <p:bgPr>
         <a:solidFill>
-          <a:srgbClr val="0E0E0C"/>
+          <a:srgbClr val="FFFFFF"/>
         </a:solidFill>
         <a:effectLst/>
       </p:bgPr>
@@ -7299,7 +7817,7 @@
             <a:pPr>
               <a:defRPr sz="1000" b="1">
                 <a:solidFill>
-                  <a:srgbClr val="7DD8C6"/>
+                  <a:srgbClr val="0F766E"/>
                 </a:solidFill>
                 <a:latin typeface="IBM Plex Mono"/>
               </a:defRPr>
@@ -7335,7 +7853,7 @@
             <a:pPr>
               <a:defRPr sz="2400" b="1">
                 <a:solidFill>
-                  <a:srgbClr val="FFFCF0"/>
+                  <a:srgbClr val="0F172A"/>
                 </a:solidFill>
                 <a:latin typeface="IBM Plex Mono"/>
               </a:defRPr>
@@ -7371,7 +7889,7 @@
             <a:pPr algn="r">
               <a:defRPr sz="1100">
                 <a:solidFill>
-                  <a:srgbClr val="5C564B"/>
+                  <a:srgbClr val="94A3B8"/>
                 </a:solidFill>
                 <a:latin typeface="IBM Plex Mono"/>
               </a:defRPr>
@@ -7396,9 +7914,9 @@
           <a:prstGeom prst="line">
             <a:avLst/>
           </a:prstGeom>
-          <a:ln w="19050">
+          <a:ln w="12700">
             <a:solidFill>
-              <a:srgbClr val="2A2A26"/>
+              <a:srgbClr val="E2E8F0"/>
             </a:solidFill>
           </a:ln>
         </p:spPr>
@@ -7419,14 +7937,111 @@
       </p:cxnSp>
       <p:sp>
         <p:nvSpPr>
-          <p:cNvPr id="6" name="TextBox 5"/>
+          <p:cNvPr id="6" name="Rectangle 5"/>
+          <p:cNvSpPr/>
+          <p:nvPr/>
+        </p:nvSpPr>
+        <p:spPr>
+          <a:xfrm>
+            <a:off x="685800" y="1280160"/>
+            <a:ext cx="10817352" cy="411480"/>
+          </a:xfrm>
+          <a:prstGeom prst="rect">
+            <a:avLst/>
+          </a:prstGeom>
+          <a:solidFill>
+            <a:srgbClr val="F1F5F9"/>
+          </a:solidFill>
+          <a:ln w="9525">
+            <a:solidFill>
+              <a:srgbClr val="4D7C0F"/>
+            </a:solidFill>
+          </a:ln>
+        </p:spPr>
+        <p:style>
+          <a:lnRef idx="1">
+            <a:schemeClr val="accent1"/>
+          </a:lnRef>
+          <a:fillRef idx="3">
+            <a:schemeClr val="accent1"/>
+          </a:fillRef>
+          <a:effectRef idx="2">
+            <a:schemeClr val="accent1"/>
+          </a:effectRef>
+          <a:fontRef idx="minor">
+            <a:schemeClr val="lt1"/>
+          </a:fontRef>
+        </p:style>
+        <p:txBody>
+          <a:bodyPr rtlCol="0" anchor="ctr" wrap="square" lIns="164592" rIns="164592" bIns="36576"/>
+          <a:lstStyle/>
+          <a:p>
+            <a:pPr algn="ctr"/>
+            <a:r>
+              <a:rPr sz="850" b="1">
+                <a:solidFill>
+                  <a:srgbClr val="4D7C0F"/>
+                </a:solidFill>
+                <a:latin typeface="IBM Plex Mono"/>
+              </a:rPr>
+              <a:t>EXAMPLE · STAGE · TRACE → NEXT-GEN GOLD</a:t>
+            </a:r>
+            <a:r>
+              <a:rPr sz="850">
+                <a:solidFill>
+                  <a:srgbClr val="94A3B8"/>
+                </a:solidFill>
+                <a:latin typeface="IBM Plex Mono"/>
+              </a:rPr>
+              <a:t>    USER INPUT → </a:t>
+            </a:r>
+            <a:r>
+              <a:rPr sz="850" i="1">
+                <a:solidFill>
+                  <a:srgbClr val="64748B"/>
+                </a:solidFill>
+                <a:latin typeface="IBM Plex Mono"/>
+              </a:rPr>
+              <a:t>“거실 조명을 50%로 켜줘”</a:t>
+            </a:r>
+          </a:p>
+          <a:p>
+            <a:pPr>
+              <a:spcBef>
+                <a:spcPts val="100"/>
+              </a:spcBef>
+            </a:pPr>
+            <a:r>
+              <a:rPr sz="1000" b="1">
+                <a:solidFill>
+                  <a:srgbClr val="4D7C0F"/>
+                </a:solidFill>
+                <a:latin typeface="IBM Plex Mono"/>
+              </a:rPr>
+              <a:t>▸  </a:t>
+            </a:r>
+            <a:r>
+              <a:rPr sz="1000" b="1">
+                <a:solidFill>
+                  <a:srgbClr val="0F172A"/>
+                </a:solidFill>
+                <a:latin typeface="IBM Plex Mono"/>
+              </a:rPr>
+              <a:t>trace.repaired{ ok:true, ir:{calls:[set_light(living,50)]} }   ⟶   next-gen SFT row</a:t>
+            </a:r>
+          </a:p>
+        </p:txBody>
+      </p:sp>
+      <p:sp>
+        <p:nvSpPr>
+          <p:cNvPr id="7" name="TextBox 6"/>
           <p:cNvSpPr txBox="1"/>
           <p:nvPr/>
         </p:nvSpPr>
         <p:spPr>
           <a:xfrm>
-            <a:off x="685800" y="1463040"/>
-            <a:ext cx="5303520" cy="4297680"/>
+            <a:off x="685800" y="1783080"/>
+            <a:ext cx="5303520" cy="4023360"/>
           </a:xfrm>
           <a:prstGeom prst="rect">
             <a:avLst/>
@@ -7445,7 +8060,7 @@
               </a:spcAft>
               <a:defRPr sz="1700" b="1">
                 <a:solidFill>
-                  <a:srgbClr val="FFFCF0"/>
+                  <a:srgbClr val="0F172A"/>
                 </a:solidFill>
                 <a:latin typeface="IBM Plex Mono"/>
               </a:defRPr>
@@ -7457,11 +8072,11 @@
           <a:p>
             <a:pPr>
               <a:spcAft>
-                <a:spcPts val="2400"/>
+                <a:spcPts val="2200"/>
               </a:spcAft>
               <a:defRPr sz="1350">
                 <a:solidFill>
-                  <a:srgbClr val="9A9485"/>
+                  <a:srgbClr val="64748B"/>
                 </a:solidFill>
                 <a:latin typeface="Arial"/>
               </a:defRPr>
@@ -7477,7 +8092,7 @@
               </a:spcAft>
               <a:defRPr sz="1700" b="1">
                 <a:solidFill>
-                  <a:srgbClr val="FFFCF0"/>
+                  <a:srgbClr val="0F172A"/>
                 </a:solidFill>
                 <a:latin typeface="IBM Plex Mono"/>
               </a:defRPr>
@@ -7490,7 +8105,7 @@
             <a:pPr>
               <a:defRPr sz="1350">
                 <a:solidFill>
-                  <a:srgbClr val="9A9485"/>
+                  <a:srgbClr val="64748B"/>
                 </a:solidFill>
                 <a:latin typeface="Arial"/>
               </a:defRPr>
@@ -7503,24 +8118,24 @@
       </p:sp>
       <p:sp>
         <p:nvSpPr>
-          <p:cNvPr id="7" name="Rectangle 6"/>
+          <p:cNvPr id="8" name="Rectangle 7"/>
           <p:cNvSpPr/>
           <p:nvPr/>
         </p:nvSpPr>
         <p:spPr>
           <a:xfrm>
-            <a:off x="6199632" y="1463040"/>
-            <a:ext cx="5303520" cy="4297680"/>
+            <a:off x="6199632" y="1783080"/>
+            <a:ext cx="5303520" cy="4023360"/>
           </a:xfrm>
           <a:prstGeom prst="rect">
             <a:avLst/>
           </a:prstGeom>
           <a:solidFill>
-            <a:srgbClr val="181C14"/>
+            <a:srgbClr val="ECFDF5"/>
           </a:solidFill>
           <a:ln w="19050">
             <a:solidFill>
-              <a:srgbClr val="C3E88D"/>
+              <a:srgbClr val="4D7C0F"/>
             </a:solidFill>
           </a:ln>
         </p:spPr>
@@ -7539,16 +8154,16 @@
           </a:fontRef>
         </p:style>
         <p:txBody>
-          <a:bodyPr rtlCol="0" anchor="ctr" wrap="square" lIns="274320" rIns="274320" tIns="365760"/>
+          <a:bodyPr rtlCol="0" anchor="t" wrap="square" lIns="274320" rIns="274320" tIns="320040"/>
           <a:lstStyle/>
           <a:p>
             <a:pPr algn="ctr">
               <a:spcAft>
-                <a:spcPts val="2000"/>
+                <a:spcPts val="1800"/>
               </a:spcAft>
               <a:defRPr sz="1800" b="1">
                 <a:solidFill>
-                  <a:srgbClr val="C3E88D"/>
+                  <a:srgbClr val="4D7C0F"/>
                 </a:solidFill>
                 <a:latin typeface="IBM Plex Mono"/>
               </a:defRPr>
@@ -7562,9 +8177,9 @@
               <a:lnSpc>
                 <a:spcPct val="130000"/>
               </a:lnSpc>
-              <a:defRPr sz="1400">
-                <a:solidFill>
-                  <a:srgbClr val="E8E4D4"/>
+              <a:defRPr sz="1350">
+                <a:solidFill>
+                  <a:srgbClr val="334155"/>
                 </a:solidFill>
                 <a:latin typeface="Arial"/>
               </a:defRPr>
@@ -7582,7 +8197,7 @@
       </p:sp>
       <p:cxnSp>
         <p:nvCxnSpPr>
-          <p:cNvPr id="8" name="Connector 7"/>
+          <p:cNvPr id="9" name="Connector 8"/>
           <p:cNvCxnSpPr/>
           <p:nvPr/>
         </p:nvCxnSpPr>
@@ -7594,9 +8209,9 @@
           <a:prstGeom prst="line">
             <a:avLst/>
           </a:prstGeom>
-          <a:ln w="19050">
+          <a:ln w="12700">
             <a:solidFill>
-              <a:srgbClr val="2A2A26"/>
+              <a:srgbClr val="E2E8F0"/>
             </a:solidFill>
           </a:ln>
         </p:spPr>
@@ -7617,7 +8232,7 @@
       </p:cxnSp>
       <p:sp>
         <p:nvSpPr>
-          <p:cNvPr id="9" name="TextBox 8"/>
+          <p:cNvPr id="10" name="TextBox 9"/>
           <p:cNvSpPr txBox="1"/>
           <p:nvPr/>
         </p:nvSpPr>
@@ -7640,7 +8255,7 @@
             <a:pPr>
               <a:defRPr sz="1000">
                 <a:solidFill>
-                  <a:srgbClr val="5C564B"/>
+                  <a:srgbClr val="94A3B8"/>
                 </a:solidFill>
                 <a:latin typeface="IBM Plex Mono"/>
               </a:defRPr>
@@ -7653,7 +8268,7 @@
       </p:sp>
       <p:sp>
         <p:nvSpPr>
-          <p:cNvPr id="10" name="TextBox 9"/>
+          <p:cNvPr id="11" name="TextBox 10"/>
           <p:cNvSpPr txBox="1"/>
           <p:nvPr/>
         </p:nvSpPr>
@@ -7676,7 +8291,7 @@
             <a:pPr algn="r">
               <a:defRPr sz="1000">
                 <a:solidFill>
-                  <a:srgbClr val="5C564B"/>
+                  <a:srgbClr val="94A3B8"/>
                 </a:solidFill>
                 <a:latin typeface="IBM Plex Mono"/>
               </a:defRPr>
@@ -7701,7 +8316,7 @@
     <p:bg>
       <p:bgPr>
         <a:solidFill>
-          <a:srgbClr val="0E0E0C"/>
+          <a:srgbClr val="FFFFFF"/>
         </a:solidFill>
         <a:effectLst/>
       </p:bgPr>
@@ -7738,7 +8353,7 @@
             <a:pPr>
               <a:defRPr sz="1000" b="1">
                 <a:solidFill>
-                  <a:srgbClr val="7DD8C6"/>
+                  <a:srgbClr val="0F766E"/>
                 </a:solidFill>
                 <a:latin typeface="IBM Plex Mono"/>
               </a:defRPr>
@@ -7774,7 +8389,7 @@
             <a:pPr>
               <a:defRPr sz="2400" b="1">
                 <a:solidFill>
-                  <a:srgbClr val="FFFCF0"/>
+                  <a:srgbClr val="0F172A"/>
                 </a:solidFill>
                 <a:latin typeface="IBM Plex Mono"/>
               </a:defRPr>
@@ -7810,7 +8425,7 @@
             <a:pPr algn="r">
               <a:defRPr sz="1100">
                 <a:solidFill>
-                  <a:srgbClr val="5C564B"/>
+                  <a:srgbClr val="94A3B8"/>
                 </a:solidFill>
                 <a:latin typeface="IBM Plex Mono"/>
               </a:defRPr>
@@ -7835,9 +8450,9 @@
           <a:prstGeom prst="line">
             <a:avLst/>
           </a:prstGeom>
-          <a:ln w="19050">
+          <a:ln w="12700">
             <a:solidFill>
-              <a:srgbClr val="2A2A26"/>
+              <a:srgbClr val="E2E8F0"/>
             </a:solidFill>
           </a:ln>
         </p:spPr>
@@ -7856,17 +8471,114 @@
           </a:fontRef>
         </p:style>
       </p:cxnSp>
+      <p:sp>
+        <p:nvSpPr>
+          <p:cNvPr id="6" name="Rectangle 5"/>
+          <p:cNvSpPr/>
+          <p:nvPr/>
+        </p:nvSpPr>
+        <p:spPr>
+          <a:xfrm>
+            <a:off x="685800" y="1280160"/>
+            <a:ext cx="10817352" cy="411480"/>
+          </a:xfrm>
+          <a:prstGeom prst="rect">
+            <a:avLst/>
+          </a:prstGeom>
+          <a:solidFill>
+            <a:srgbClr val="F1F5F9"/>
+          </a:solidFill>
+          <a:ln w="9525">
+            <a:solidFill>
+              <a:srgbClr val="0F766E"/>
+            </a:solidFill>
+          </a:ln>
+        </p:spPr>
+        <p:style>
+          <a:lnRef idx="1">
+            <a:schemeClr val="accent1"/>
+          </a:lnRef>
+          <a:fillRef idx="3">
+            <a:schemeClr val="accent1"/>
+          </a:fillRef>
+          <a:effectRef idx="2">
+            <a:schemeClr val="accent1"/>
+          </a:effectRef>
+          <a:fontRef idx="minor">
+            <a:schemeClr val="lt1"/>
+          </a:fontRef>
+        </p:style>
+        <p:txBody>
+          <a:bodyPr rtlCol="0" anchor="ctr" wrap="square" lIns="164592" rIns="164592" bIns="36576"/>
+          <a:lstStyle/>
+          <a:p>
+            <a:pPr algn="ctr"/>
+            <a:r>
+              <a:rPr sz="850" b="1">
+                <a:solidFill>
+                  <a:srgbClr val="0F766E"/>
+                </a:solidFill>
+                <a:latin typeface="IBM Plex Mono"/>
+              </a:rPr>
+              <a:t>EXAMPLE · STAGE · MEASURED ON THIS CASE</a:t>
+            </a:r>
+            <a:r>
+              <a:rPr sz="850">
+                <a:solidFill>
+                  <a:srgbClr val="94A3B8"/>
+                </a:solidFill>
+                <a:latin typeface="IBM Plex Mono"/>
+              </a:rPr>
+              <a:t>    USER INPUT → </a:t>
+            </a:r>
+            <a:r>
+              <a:rPr sz="850" i="1">
+                <a:solidFill>
+                  <a:srgbClr val="64748B"/>
+                </a:solidFill>
+                <a:latin typeface="IBM Plex Mono"/>
+              </a:rPr>
+              <a:t>“거실 조명을 50%로 켜줘”</a:t>
+            </a:r>
+          </a:p>
+          <a:p>
+            <a:pPr>
+              <a:spcBef>
+                <a:spcPts val="100"/>
+              </a:spcBef>
+            </a:pPr>
+            <a:r>
+              <a:rPr sz="1000" b="1">
+                <a:solidFill>
+                  <a:srgbClr val="0F766E"/>
+                </a:solidFill>
+                <a:latin typeface="IBM Plex Mono"/>
+              </a:rPr>
+              <a:t>▸  </a:t>
+            </a:r>
+            <a:r>
+              <a:rPr sz="1000" b="1">
+                <a:solidFill>
+                  <a:srgbClr val="0F172A"/>
+                </a:solidFill>
+                <a:latin typeface="IBM Plex Mono"/>
+              </a:rPr>
+              <a:t>Native baseline:  287 tok / 482 ms      Ganglion:  92 tok / 391 ms       Δ  −68% tok,  −19% lat</a:t>
+            </a:r>
+          </a:p>
+        </p:txBody>
+      </p:sp>
       <p:graphicFrame>
         <p:nvGraphicFramePr>
-          <p:cNvPr id="6" name="Table 5"/>
+          <p:cNvPr id="7" name="Table 6"/>
           <p:cNvGraphicFramePr>
             <a:graphicFrameLocks noGrp="1"/>
           </p:cNvGraphicFramePr>
           <p:nvPr/>
         </p:nvGraphicFramePr>
         <p:xfrm>
-          <a:off x="685800" y="1463040"/>
-          <a:ext cx="5669280" cy="4114800"/>
+          <a:off x="685800" y="1783080"/>
+          <a:ext cx="5669280" cy="3840480"/>
         </p:xfrm>
         <a:graphic>
           <a:graphicData uri="http://schemas.openxmlformats.org/drawingml/2006/table">
@@ -7879,7 +8591,7 @@
                 <a:gridCol w="2011680"/>
                 <a:gridCol w="1828800"/>
               </a:tblGrid>
-              <a:tr h="822960">
+              <a:tr h="768096">
                 <a:tc>
                   <a:txBody>
                     <a:bodyPr/>
@@ -7888,7 +8600,7 @@
                       <a:pPr>
                         <a:defRPr sz="1100" b="1">
                           <a:solidFill>
-                            <a:srgbClr val="9A9485"/>
+                            <a:srgbClr val="0F172A"/>
                           </a:solidFill>
                           <a:latin typeface="IBM Plex Mono"/>
                         </a:defRPr>
@@ -7900,7 +8612,7 @@
                   </a:txBody>
                   <a:tcPr>
                     <a:solidFill>
-                      <a:srgbClr val="181814"/>
+                      <a:srgbClr val="F1F5F9"/>
                     </a:solidFill>
                   </a:tcPr>
                 </a:tc>
@@ -7912,7 +8624,7 @@
                       <a:pPr>
                         <a:defRPr sz="1100" b="1">
                           <a:solidFill>
-                            <a:srgbClr val="9A9485"/>
+                            <a:srgbClr val="0F172A"/>
                           </a:solidFill>
                           <a:latin typeface="IBM Plex Mono"/>
                         </a:defRPr>
@@ -7924,7 +8636,7 @@
                   </a:txBody>
                   <a:tcPr>
                     <a:solidFill>
-                      <a:srgbClr val="181814"/>
+                      <a:srgbClr val="F1F5F9"/>
                     </a:solidFill>
                   </a:tcPr>
                 </a:tc>
@@ -7936,7 +8648,7 @@
                       <a:pPr>
                         <a:defRPr sz="1100" b="1">
                           <a:solidFill>
-                            <a:srgbClr val="9A9485"/>
+                            <a:srgbClr val="0F172A"/>
                           </a:solidFill>
                           <a:latin typeface="IBM Plex Mono"/>
                         </a:defRPr>
@@ -7948,12 +8660,12 @@
                   </a:txBody>
                   <a:tcPr>
                     <a:solidFill>
-                      <a:srgbClr val="181814"/>
+                      <a:srgbClr val="F1F5F9"/>
                     </a:solidFill>
                   </a:tcPr>
                 </a:tc>
               </a:tr>
-              <a:tr h="822960">
+              <a:tr h="768096">
                 <a:tc>
                   <a:txBody>
                     <a:bodyPr/>
@@ -7962,7 +8674,7 @@
                       <a:pPr>
                         <a:defRPr sz="1150" b="0">
                           <a:solidFill>
-                            <a:srgbClr val="E8E4D4"/>
+                            <a:srgbClr val="334155"/>
                           </a:solidFill>
                           <a:latin typeface="IBM Plex Mono"/>
                         </a:defRPr>
@@ -7974,7 +8686,7 @@
                   </a:txBody>
                   <a:tcPr>
                     <a:solidFill>
-                      <a:srgbClr val="0E0E0C"/>
+                      <a:srgbClr val="F8FAFC"/>
                     </a:solidFill>
                   </a:tcPr>
                 </a:tc>
@@ -7986,7 +8698,7 @@
                       <a:pPr>
                         <a:defRPr sz="1150" b="0">
                           <a:solidFill>
-                            <a:srgbClr val="E8E4D4"/>
+                            <a:srgbClr val="334155"/>
                           </a:solidFill>
                           <a:latin typeface="IBM Plex Mono"/>
                         </a:defRPr>
@@ -7998,7 +8710,7 @@
                   </a:txBody>
                   <a:tcPr>
                     <a:solidFill>
-                      <a:srgbClr val="0E0E0C"/>
+                      <a:srgbClr val="F8FAFC"/>
                     </a:solidFill>
                   </a:tcPr>
                 </a:tc>
@@ -8010,7 +8722,7 @@
                       <a:pPr>
                         <a:defRPr sz="1150" b="1">
                           <a:solidFill>
-                            <a:srgbClr val="C3E88D"/>
+                            <a:srgbClr val="4D7C0F"/>
                           </a:solidFill>
                           <a:latin typeface="IBM Plex Mono"/>
                         </a:defRPr>
@@ -8022,12 +8734,12 @@
                   </a:txBody>
                   <a:tcPr>
                     <a:solidFill>
-                      <a:srgbClr val="0E0E0C"/>
+                      <a:srgbClr val="F8FAFC"/>
                     </a:solidFill>
                   </a:tcPr>
                 </a:tc>
               </a:tr>
-              <a:tr h="822960">
+              <a:tr h="768096">
                 <a:tc>
                   <a:txBody>
                     <a:bodyPr/>
@@ -8036,7 +8748,7 @@
                       <a:pPr>
                         <a:defRPr sz="1150" b="0">
                           <a:solidFill>
-                            <a:srgbClr val="E8E4D4"/>
+                            <a:srgbClr val="334155"/>
                           </a:solidFill>
                           <a:latin typeface="IBM Plex Mono"/>
                         </a:defRPr>
@@ -8048,7 +8760,7 @@
                   </a:txBody>
                   <a:tcPr>
                     <a:solidFill>
-                      <a:srgbClr val="0E0E0C"/>
+                      <a:srgbClr val="F8FAFC"/>
                     </a:solidFill>
                   </a:tcPr>
                 </a:tc>
@@ -8060,7 +8772,7 @@
                       <a:pPr>
                         <a:defRPr sz="1150" b="0">
                           <a:solidFill>
-                            <a:srgbClr val="E8E4D4"/>
+                            <a:srgbClr val="334155"/>
                           </a:solidFill>
                           <a:latin typeface="IBM Plex Mono"/>
                         </a:defRPr>
@@ -8072,7 +8784,7 @@
                   </a:txBody>
                   <a:tcPr>
                     <a:solidFill>
-                      <a:srgbClr val="0E0E0C"/>
+                      <a:srgbClr val="F8FAFC"/>
                     </a:solidFill>
                   </a:tcPr>
                 </a:tc>
@@ -8084,7 +8796,7 @@
                       <a:pPr>
                         <a:defRPr sz="1150" b="1">
                           <a:solidFill>
-                            <a:srgbClr val="C3E88D"/>
+                            <a:srgbClr val="4D7C0F"/>
                           </a:solidFill>
                           <a:latin typeface="IBM Plex Mono"/>
                         </a:defRPr>
@@ -8096,12 +8808,12 @@
                   </a:txBody>
                   <a:tcPr>
                     <a:solidFill>
-                      <a:srgbClr val="0E0E0C"/>
+                      <a:srgbClr val="F8FAFC"/>
                     </a:solidFill>
                   </a:tcPr>
                 </a:tc>
               </a:tr>
-              <a:tr h="822960">
+              <a:tr h="768096">
                 <a:tc>
                   <a:txBody>
                     <a:bodyPr/>
@@ -8110,7 +8822,7 @@
                       <a:pPr>
                         <a:defRPr sz="1150" b="0">
                           <a:solidFill>
-                            <a:srgbClr val="E8E4D4"/>
+                            <a:srgbClr val="334155"/>
                           </a:solidFill>
                           <a:latin typeface="IBM Plex Mono"/>
                         </a:defRPr>
@@ -8122,7 +8834,7 @@
                   </a:txBody>
                   <a:tcPr>
                     <a:solidFill>
-                      <a:srgbClr val="0E0E0C"/>
+                      <a:srgbClr val="F8FAFC"/>
                     </a:solidFill>
                   </a:tcPr>
                 </a:tc>
@@ -8134,7 +8846,7 @@
                       <a:pPr>
                         <a:defRPr sz="1150" b="0">
                           <a:solidFill>
-                            <a:srgbClr val="E8E4D4"/>
+                            <a:srgbClr val="334155"/>
                           </a:solidFill>
                           <a:latin typeface="IBM Plex Mono"/>
                         </a:defRPr>
@@ -8146,7 +8858,57 @@
                   </a:txBody>
                   <a:tcPr>
                     <a:solidFill>
-                      <a:srgbClr val="0E0E0C"/>
+                      <a:srgbClr val="F8FAFC"/>
+                    </a:solidFill>
+                  </a:tcPr>
+                </a:tc>
+                <a:tc>
+                  <a:txBody>
+                    <a:bodyPr/>
+                    <a:lstStyle/>
+                    <a:p>
+                      <a:pPr>
+                        <a:defRPr sz="1150" b="1">
+                          <a:solidFill>
+                            <a:srgbClr val="4D7C0F"/>
+                          </a:solidFill>
+                          <a:latin typeface="IBM Plex Mono"/>
+                        </a:defRPr>
+                      </a:pPr>
+                      <a:r>
+                        <a:t>91.2% vs 31.4% (+59.8%)</a:t>
+                      </a:r>
+                    </a:p>
+                  </a:txBody>
+                  <a:tcPr>
+                    <a:solidFill>
+                      <a:srgbClr val="F8FAFC"/>
+                    </a:solidFill>
+                  </a:tcPr>
+                </a:tc>
+              </a:tr>
+              <a:tr h="768096">
+                <a:tc>
+                  <a:txBody>
+                    <a:bodyPr/>
+                    <a:lstStyle/>
+                    <a:p>
+                      <a:pPr>
+                        <a:defRPr sz="1150" b="0">
+                          <a:solidFill>
+                            <a:srgbClr val="334155"/>
+                          </a:solidFill>
+                          <a:latin typeface="IBM Plex Mono"/>
+                        </a:defRPr>
+                      </a:pPr>
+                      <a:r>
+                        <a:t>BFCL (Irrelevance)</a:t>
+                      </a:r>
+                    </a:p>
+                  </a:txBody>
+                  <a:tcPr>
+                    <a:solidFill>
+                      <a:srgbClr val="F8FAFC"/>
                     </a:solidFill>
                   </a:tcPr>
                 </a:tc>
@@ -8158,57 +8920,7 @@
                       <a:pPr>
                         <a:defRPr sz="1150" b="0">
                           <a:solidFill>
-                            <a:srgbClr val="C3E88D"/>
-                          </a:solidFill>
-                          <a:latin typeface="IBM Plex Mono"/>
-                        </a:defRPr>
-                      </a:pPr>
-                      <a:r>
-                        <a:t>91.2% vs 31.4% (+59.8%)</a:t>
-                      </a:r>
-                    </a:p>
-                  </a:txBody>
-                  <a:tcPr>
-                    <a:solidFill>
-                      <a:srgbClr val="0E0E0C"/>
-                    </a:solidFill>
-                  </a:tcPr>
-                </a:tc>
-              </a:tr>
-              <a:tr h="822960">
-                <a:tc>
-                  <a:txBody>
-                    <a:bodyPr/>
-                    <a:lstStyle/>
-                    <a:p>
-                      <a:pPr>
-                        <a:defRPr sz="1150" b="0">
-                          <a:solidFill>
-                            <a:srgbClr val="E8E4D4"/>
-                          </a:solidFill>
-                          <a:latin typeface="IBM Plex Mono"/>
-                        </a:defRPr>
-                      </a:pPr>
-                      <a:r>
-                        <a:t>BFCL (Irrelevance)</a:t>
-                      </a:r>
-                    </a:p>
-                  </a:txBody>
-                  <a:tcPr>
-                    <a:solidFill>
-                      <a:srgbClr val="0E0E0C"/>
-                    </a:solidFill>
-                  </a:tcPr>
-                </a:tc>
-                <a:tc>
-                  <a:txBody>
-                    <a:bodyPr/>
-                    <a:lstStyle/>
-                    <a:p>
-                      <a:pPr>
-                        <a:defRPr sz="1150" b="0">
-                          <a:solidFill>
-                            <a:srgbClr val="E8E4D4"/>
+                            <a:srgbClr val="334155"/>
                           </a:solidFill>
                           <a:latin typeface="IBM Plex Mono"/>
                         </a:defRPr>
@@ -8220,7 +8932,7 @@
                   </a:txBody>
                   <a:tcPr>
                     <a:solidFill>
-                      <a:srgbClr val="0E0E0C"/>
+                      <a:srgbClr val="F8FAFC"/>
                     </a:solidFill>
                   </a:tcPr>
                 </a:tc>
@@ -8230,9 +8942,9 @@
                     <a:lstStyle/>
                     <a:p>
                       <a:pPr>
-                        <a:defRPr sz="1150" b="0">
+                        <a:defRPr sz="1150" b="1">
                           <a:solidFill>
-                            <a:srgbClr val="C3E88D"/>
+                            <a:srgbClr val="4D7C0F"/>
                           </a:solidFill>
                           <a:latin typeface="IBM Plex Mono"/>
                         </a:defRPr>
@@ -8244,7 +8956,7 @@
                   </a:txBody>
                   <a:tcPr>
                     <a:solidFill>
-                      <a:srgbClr val="0E0E0C"/>
+                      <a:srgbClr val="F8FAFC"/>
                     </a:solidFill>
                   </a:tcPr>
                 </a:tc>
@@ -8255,13 +8967,13 @@
       </p:graphicFrame>
       <p:sp>
         <p:nvSpPr>
-          <p:cNvPr id="7" name="TextBox 6"/>
+          <p:cNvPr id="8" name="TextBox 7"/>
           <p:cNvSpPr txBox="1"/>
           <p:nvPr/>
         </p:nvSpPr>
         <p:spPr>
           <a:xfrm>
-            <a:off x="6675120" y="1463040"/>
+            <a:off x="6675120" y="1783080"/>
             <a:ext cx="4846320" cy="457200"/>
           </a:xfrm>
           <a:prstGeom prst="rect">
@@ -8278,7 +8990,7 @@
             <a:pPr>
               <a:defRPr sz="1600" b="1">
                 <a:solidFill>
-                  <a:srgbClr val="7DD8C6"/>
+                  <a:srgbClr val="0F766E"/>
                 </a:solidFill>
                 <a:latin typeface="IBM Plex Mono"/>
               </a:defRPr>
@@ -8291,24 +9003,24 @@
       </p:sp>
       <p:sp>
         <p:nvSpPr>
-          <p:cNvPr id="8" name="Rectangle 7"/>
+          <p:cNvPr id="9" name="Rectangle 8"/>
           <p:cNvSpPr/>
           <p:nvPr/>
         </p:nvSpPr>
         <p:spPr>
           <a:xfrm>
-            <a:off x="6675120" y="2011680"/>
-            <a:ext cx="2286000" cy="1371600"/>
+            <a:off x="6675120" y="2331720"/>
+            <a:ext cx="2286000" cy="1325880"/>
           </a:xfrm>
           <a:prstGeom prst="rect">
             <a:avLst/>
           </a:prstGeom>
           <a:solidFill>
-            <a:srgbClr val="181814"/>
+            <a:srgbClr val="F8FAFC"/>
           </a:solidFill>
           <a:ln w="19050">
             <a:solidFill>
-              <a:srgbClr val="3D3D36"/>
+              <a:srgbClr val="B45309"/>
             </a:solidFill>
           </a:ln>
         </p:spPr>
@@ -8333,7 +9045,7 @@
             <a:pPr algn="ctr">
               <a:defRPr sz="2800" b="1">
                 <a:solidFill>
-                  <a:srgbClr val="F4B860"/>
+                  <a:srgbClr val="B45309"/>
                 </a:solidFill>
                 <a:latin typeface="IBM Plex Mono"/>
               </a:defRPr>
@@ -8349,7 +9061,7 @@
               </a:spcBef>
               <a:defRPr sz="1000">
                 <a:solidFill>
-                  <a:srgbClr val="9A9485"/>
+                  <a:srgbClr val="64748B"/>
                 </a:solidFill>
                 <a:latin typeface="Arial"/>
               </a:defRPr>
@@ -8366,24 +9078,24 @@
       </p:sp>
       <p:sp>
         <p:nvSpPr>
-          <p:cNvPr id="9" name="Rectangle 8"/>
+          <p:cNvPr id="10" name="Rectangle 9"/>
           <p:cNvSpPr/>
           <p:nvPr/>
         </p:nvSpPr>
         <p:spPr>
           <a:xfrm>
-            <a:off x="9235440" y="2011680"/>
-            <a:ext cx="2286000" cy="1371600"/>
+            <a:off x="9235440" y="2331720"/>
+            <a:ext cx="2286000" cy="1325880"/>
           </a:xfrm>
           <a:prstGeom prst="rect">
             <a:avLst/>
           </a:prstGeom>
           <a:solidFill>
-            <a:srgbClr val="181814"/>
+            <a:srgbClr val="F8FAFC"/>
           </a:solidFill>
           <a:ln w="19050">
             <a:solidFill>
-              <a:srgbClr val="C3E88D"/>
+              <a:srgbClr val="4D7C0F"/>
             </a:solidFill>
           </a:ln>
         </p:spPr>
@@ -8408,7 +9120,7 @@
             <a:pPr algn="ctr">
               <a:defRPr sz="2800" b="1">
                 <a:solidFill>
-                  <a:srgbClr val="C3E88D"/>
+                  <a:srgbClr val="4D7C0F"/>
                 </a:solidFill>
                 <a:latin typeface="IBM Plex Mono"/>
               </a:defRPr>
@@ -8424,7 +9136,7 @@
               </a:spcBef>
               <a:defRPr sz="1000">
                 <a:solidFill>
-                  <a:srgbClr val="9A9485"/>
+                  <a:srgbClr val="64748B"/>
                 </a:solidFill>
                 <a:latin typeface="Arial"/>
               </a:defRPr>
@@ -8441,14 +9153,14 @@
       </p:sp>
       <p:sp>
         <p:nvSpPr>
-          <p:cNvPr id="10" name="TextBox 9"/>
+          <p:cNvPr id="11" name="TextBox 10"/>
           <p:cNvSpPr txBox="1"/>
           <p:nvPr/>
         </p:nvSpPr>
         <p:spPr>
           <a:xfrm>
-            <a:off x="6675120" y="3566160"/>
-            <a:ext cx="4846320" cy="2011680"/>
+            <a:off x="6675120" y="3840480"/>
+            <a:ext cx="4846320" cy="1828800"/>
           </a:xfrm>
           <a:prstGeom prst="rect">
             <a:avLst/>
@@ -8465,9 +9177,9 @@
               <a:lnSpc>
                 <a:spcPct val="130000"/>
               </a:lnSpc>
-              <a:defRPr sz="1200">
-                <a:solidFill>
-                  <a:srgbClr val="E8E4D4"/>
+              <a:defRPr sz="1150">
+                <a:solidFill>
+                  <a:srgbClr val="334155"/>
                 </a:solidFill>
                 <a:latin typeface="Arial"/>
               </a:defRPr>
@@ -8485,7 +9197,7 @@
       </p:sp>
       <p:cxnSp>
         <p:nvCxnSpPr>
-          <p:cNvPr id="11" name="Connector 10"/>
+          <p:cNvPr id="12" name="Connector 11"/>
           <p:cNvCxnSpPr/>
           <p:nvPr/>
         </p:nvCxnSpPr>
@@ -8497,9 +9209,9 @@
           <a:prstGeom prst="line">
             <a:avLst/>
           </a:prstGeom>
-          <a:ln w="19050">
+          <a:ln w="12700">
             <a:solidFill>
-              <a:srgbClr val="2A2A26"/>
+              <a:srgbClr val="E2E8F0"/>
             </a:solidFill>
           </a:ln>
         </p:spPr>
@@ -8520,7 +9232,7 @@
       </p:cxnSp>
       <p:sp>
         <p:nvSpPr>
-          <p:cNvPr id="12" name="TextBox 11"/>
+          <p:cNvPr id="13" name="TextBox 12"/>
           <p:cNvSpPr txBox="1"/>
           <p:nvPr/>
         </p:nvSpPr>
@@ -8543,7 +9255,7 @@
             <a:pPr>
               <a:defRPr sz="1000">
                 <a:solidFill>
-                  <a:srgbClr val="5C564B"/>
+                  <a:srgbClr val="94A3B8"/>
                 </a:solidFill>
                 <a:latin typeface="IBM Plex Mono"/>
               </a:defRPr>
@@ -8556,7 +9268,7 @@
       </p:sp>
       <p:sp>
         <p:nvSpPr>
-          <p:cNvPr id="13" name="TextBox 12"/>
+          <p:cNvPr id="14" name="TextBox 13"/>
           <p:cNvSpPr txBox="1"/>
           <p:nvPr/>
         </p:nvSpPr>
@@ -8579,7 +9291,7 @@
             <a:pPr algn="r">
               <a:defRPr sz="1000">
                 <a:solidFill>
-                  <a:srgbClr val="5C564B"/>
+                  <a:srgbClr val="94A3B8"/>
                 </a:solidFill>
                 <a:latin typeface="IBM Plex Mono"/>
               </a:defRPr>
@@ -8604,7 +9316,7 @@
     <p:bg>
       <p:bgPr>
         <a:solidFill>
-          <a:srgbClr val="0E0E0C"/>
+          <a:srgbClr val="FFFFFF"/>
         </a:solidFill>
         <a:effectLst/>
       </p:bgPr>
@@ -8641,7 +9353,7 @@
             <a:pPr>
               <a:defRPr sz="1000" b="1">
                 <a:solidFill>
-                  <a:srgbClr val="7DD8C6"/>
+                  <a:srgbClr val="0F766E"/>
                 </a:solidFill>
                 <a:latin typeface="IBM Plex Mono"/>
               </a:defRPr>
@@ -8677,7 +9389,7 @@
             <a:pPr>
               <a:defRPr sz="2400" b="1">
                 <a:solidFill>
-                  <a:srgbClr val="FFFCF0"/>
+                  <a:srgbClr val="0F172A"/>
                 </a:solidFill>
                 <a:latin typeface="IBM Plex Mono"/>
               </a:defRPr>
@@ -8713,7 +9425,7 @@
             <a:pPr algn="r">
               <a:defRPr sz="1100">
                 <a:solidFill>
-                  <a:srgbClr val="5C564B"/>
+                  <a:srgbClr val="94A3B8"/>
                 </a:solidFill>
                 <a:latin typeface="IBM Plex Mono"/>
               </a:defRPr>
@@ -8738,9 +9450,9 @@
           <a:prstGeom prst="line">
             <a:avLst/>
           </a:prstGeom>
-          <a:ln w="19050">
+          <a:ln w="12700">
             <a:solidFill>
-              <a:srgbClr val="2A2A26"/>
+              <a:srgbClr val="E2E8F0"/>
             </a:solidFill>
           </a:ln>
         </p:spPr>
@@ -8787,7 +9499,7 @@
               </a:spcAft>
               <a:defRPr sz="1800" b="1">
                 <a:solidFill>
-                  <a:srgbClr val="7DD8C6"/>
+                  <a:srgbClr val="0F766E"/>
                 </a:solidFill>
                 <a:latin typeface="IBM Plex Mono"/>
               </a:defRPr>
@@ -8803,7 +9515,7 @@
               </a:spcAft>
               <a:defRPr sz="1450" b="1">
                 <a:solidFill>
-                  <a:srgbClr val="FFFCF0"/>
+                  <a:srgbClr val="0F172A"/>
                 </a:solidFill>
                 <a:latin typeface="IBM Plex Mono"/>
               </a:defRPr>
@@ -8819,7 +9531,7 @@
               </a:spcAft>
               <a:defRPr sz="1300">
                 <a:solidFill>
-                  <a:srgbClr val="9A9485"/>
+                  <a:srgbClr val="64748B"/>
                 </a:solidFill>
                 <a:latin typeface="Arial"/>
               </a:defRPr>
@@ -8835,7 +9547,7 @@
               </a:spcAft>
               <a:defRPr sz="1450" b="1">
                 <a:solidFill>
-                  <a:srgbClr val="FFFCF0"/>
+                  <a:srgbClr val="0F172A"/>
                 </a:solidFill>
                 <a:latin typeface="IBM Plex Mono"/>
               </a:defRPr>
@@ -8848,7 +9560,7 @@
             <a:pPr>
               <a:defRPr sz="1300">
                 <a:solidFill>
-                  <a:srgbClr val="9A9485"/>
+                  <a:srgbClr val="64748B"/>
                 </a:solidFill>
                 <a:latin typeface="Arial"/>
               </a:defRPr>
@@ -8887,7 +9599,7 @@
               </a:spcAft>
               <a:defRPr sz="1800" b="1">
                 <a:solidFill>
-                  <a:srgbClr val="F4B860"/>
+                  <a:srgbClr val="B45309"/>
                 </a:solidFill>
                 <a:latin typeface="IBM Plex Mono"/>
               </a:defRPr>
@@ -8903,7 +9615,7 @@
               </a:spcAft>
               <a:defRPr sz="1450" b="1">
                 <a:solidFill>
-                  <a:srgbClr val="FFFCF0"/>
+                  <a:srgbClr val="0F172A"/>
                 </a:solidFill>
                 <a:latin typeface="IBM Plex Mono"/>
               </a:defRPr>
@@ -8919,7 +9631,7 @@
               </a:spcAft>
               <a:defRPr sz="1300">
                 <a:solidFill>
-                  <a:srgbClr val="9A9485"/>
+                  <a:srgbClr val="64748B"/>
                 </a:solidFill>
                 <a:latin typeface="Arial"/>
               </a:defRPr>
@@ -8935,7 +9647,7 @@
               </a:spcAft>
               <a:defRPr sz="1450" b="1">
                 <a:solidFill>
-                  <a:srgbClr val="FFFCF0"/>
+                  <a:srgbClr val="0F172A"/>
                 </a:solidFill>
                 <a:latin typeface="IBM Plex Mono"/>
               </a:defRPr>
@@ -8948,7 +9660,7 @@
             <a:pPr>
               <a:defRPr sz="1300">
                 <a:solidFill>
-                  <a:srgbClr val="9A9485"/>
+                  <a:srgbClr val="64748B"/>
                 </a:solidFill>
                 <a:latin typeface="Arial"/>
               </a:defRPr>
@@ -8973,9 +9685,9 @@
           <a:prstGeom prst="line">
             <a:avLst/>
           </a:prstGeom>
-          <a:ln w="19050">
+          <a:ln w="12700">
             <a:solidFill>
-              <a:srgbClr val="2A2A26"/>
+              <a:srgbClr val="E2E8F0"/>
             </a:solidFill>
           </a:ln>
         </p:spPr>
@@ -9019,7 +9731,7 @@
             <a:pPr>
               <a:defRPr sz="1000">
                 <a:solidFill>
-                  <a:srgbClr val="5C564B"/>
+                  <a:srgbClr val="94A3B8"/>
                 </a:solidFill>
                 <a:latin typeface="IBM Plex Mono"/>
               </a:defRPr>
@@ -9055,7 +9767,7 @@
             <a:pPr algn="r">
               <a:defRPr sz="1000">
                 <a:solidFill>
-                  <a:srgbClr val="5C564B"/>
+                  <a:srgbClr val="94A3B8"/>
                 </a:solidFill>
                 <a:latin typeface="IBM Plex Mono"/>
               </a:defRPr>

</xml_diff>